<commit_message>
fix: update domain to real snz.web.id
</commit_message>
<xml_diff>
--- a/Portofolio_Bisnis_SANZ_GOKU.pptx
+++ b/Portofolio_Bisnis_SANZ_GOKU.pptx
@@ -3480,7 +3480,7 @@
               </a:defRPr>
             </a:pPr>
             <a:r>
-              <a:t>Domain: snz.my.id  ·  Bot: @Sanzstrnokosmumerbot  ·  Admin: @Sanzxgoku</a:t>
+              <a:t>Domain: snz.web.id  ·  Bot: @Sanzstrnokosmumerbot  ·  Admin: @Sanzxgoku</a:t>
             </a:r>
           </a:p>
         </p:txBody>
@@ -3516,7 +3516,7 @@
               </a:defRPr>
             </a:pPr>
             <a:r>
-              <a:t>SANZ GOKU  ·  Satu Bot, Banyak Solusi  ·  snz.my.id                           SLIDE 01 / 08</a:t>
+              <a:t>SANZ GOKU  ·  Satu Bot, Banyak Solusi  ·  snz.web.id                           SLIDE 01 / 08</a:t>
             </a:r>
           </a:p>
         </p:txBody>
@@ -3827,7 +3827,7 @@
             </a:r>
             <a:br/>
             <a:r>
-              <a:t>Domain: snz.my.id</a:t>
+              <a:t>Domain: snz.web.id</a:t>
             </a:r>
             <a:br/>
             <a:r>
@@ -4391,7 +4391,7 @@
               </a:defRPr>
             </a:pPr>
             <a:r>
-              <a:t>SANZ GOKU  ·  Satu Bot, Banyak Solusi  ·  snz.my.id                           SLIDE 02 / 08</a:t>
+              <a:t>SANZ GOKU  ·  Satu Bot, Banyak Solusi  ·  snz.web.id                           SLIDE 02 / 08</a:t>
             </a:r>
           </a:p>
         </p:txBody>
@@ -5278,7 +5278,7 @@
               </a:defRPr>
             </a:pPr>
             <a:r>
-              <a:t>SANZ GOKU  ·  Satu Bot, Banyak Solusi  ·  snz.my.id                           SLIDE 03 / 08</a:t>
+              <a:t>SANZ GOKU  ·  Satu Bot, Banyak Solusi  ·  snz.web.id                           SLIDE 03 / 08</a:t>
             </a:r>
           </a:p>
         </p:txBody>
@@ -6127,7 +6127,7 @@
               </a:defRPr>
             </a:pPr>
             <a:r>
-              <a:t>SANZ GOKU  ·  Satu Bot, Banyak Solusi  ·  snz.my.id                           SLIDE 04 / 08</a:t>
+              <a:t>SANZ GOKU  ·  Satu Bot, Banyak Solusi  ·  snz.web.id                           SLIDE 04 / 08</a:t>
             </a:r>
           </a:p>
         </p:txBody>
@@ -6773,7 +6773,7 @@
               </a:defRPr>
             </a:pPr>
             <a:r>
-              <a:t>Bot Telegram: @Sanzstrnokosmumerbot  |  Admin: @Sanzxgoku  |  Instagram: @sanzshun  |  Domain: snz.my.id</a:t>
+              <a:t>Bot Telegram: @Sanzstrnokosmumerbot  |  Admin: @Sanzxgoku  |  Instagram: @sanzshun  |  Domain: snz.web.id</a:t>
             </a:r>
           </a:p>
         </p:txBody>
@@ -6809,7 +6809,7 @@
               </a:defRPr>
             </a:pPr>
             <a:r>
-              <a:t>SANZ GOKU  ·  Satu Bot, Banyak Solusi  ·  snz.my.id                           SLIDE 05 / 08</a:t>
+              <a:t>SANZ GOKU  ·  Satu Bot, Banyak Solusi  ·  snz.web.id                           SLIDE 05 / 08</a:t>
             </a:r>
           </a:p>
         </p:txBody>
@@ -7245,7 +7245,7 @@
               </a:defRPr>
             </a:pPr>
             <a:r>
-              <a:t>Manajemen domain snz.my.id, proteksi terhadap serangan DDoS, serta pengaturan routing subdomain.</a:t>
+              <a:t>Manajemen domain snz.web.id, proteksi terhadap serangan DDoS, serta pengaturan routing subdomain.</a:t>
             </a:r>
           </a:p>
         </p:txBody>
@@ -7460,7 +7460,7 @@
               </a:defRPr>
             </a:pPr>
             <a:r>
-              <a:t>SANZ GOKU  ·  Satu Bot, Banyak Solusi  ·  snz.my.id                           SLIDE 06 / 08</a:t>
+              <a:t>SANZ GOKU  ·  Satu Bot, Banyak Solusi  ·  snz.web.id                           SLIDE 06 / 08</a:t>
             </a:r>
           </a:p>
         </p:txBody>
@@ -8140,7 +8140,7 @@
               </a:defRPr>
             </a:pPr>
             <a:r>
-              <a:t>Mengintegrasikan website (snz.my.id), bot Telegram, dan panel server menjadi satu ekosistem bisnis digital yang stabil.</a:t>
+              <a:t>Mengintegrasikan website (snz.web.id), bot Telegram, dan panel server menjadi satu ekosistem bisnis digital yang stabil.</a:t>
             </a:r>
           </a:p>
         </p:txBody>
@@ -8176,7 +8176,7 @@
               </a:defRPr>
             </a:pPr>
             <a:r>
-              <a:t>SANZ GOKU  ·  Satu Bot, Banyak Solusi  ·  snz.my.id                           SLIDE 07 / 08</a:t>
+              <a:t>SANZ GOKU  ·  Satu Bot, Banyak Solusi  ·  snz.web.id                           SLIDE 07 / 08</a:t>
             </a:r>
           </a:p>
         </p:txBody>
@@ -8703,7 +8703,7 @@
               </a:defRPr>
             </a:pPr>
             <a:r>
-              <a:t>• Domain Bisnis: snz.my.id</a:t>
+              <a:t>• Domain Bisnis: snz.web.id</a:t>
             </a:r>
           </a:p>
         </p:txBody>
@@ -8739,7 +8739,7 @@
               </a:defRPr>
             </a:pPr>
             <a:r>
-              <a:t>SANZ GOKU  ·  Satu Bot, Banyak Solusi  ·  snz.my.id                           SLIDE 08 / 08</a:t>
+              <a:t>SANZ GOKU  ·  Satu Bot, Banyak Solusi  ·  snz.web.id                           SLIDE 08 / 08</a:t>
             </a:r>
           </a:p>
         </p:txBody>

</xml_diff>

<commit_message>
feat: overhaul PPTX and slide viewer to 100% authentic Persona 5 aesthetic
</commit_message>
<xml_diff>
--- a/Portofolio_Bisnis_SANZ_GOKU.pptx
+++ b/Portofolio_Bisnis_SANZ_GOKU.pptx
@@ -3095,61 +3095,42 @@
         <p:nvPr/>
       </p:nvGrpSpPr>
       <p:grpSpPr/>
-      <p:sp>
-        <p:nvSpPr>
-          <p:cNvPr id="2" name="Rectangle 1"/>
+      <p:pic>
+        <p:nvPicPr>
+          <p:cNvPr id="2" name="Picture 1" descr="bg_slide1.jpg"/>
+          <p:cNvPicPr>
+            <a:picLocks noChangeAspect="1"/>
+          </p:cNvPicPr>
+          <p:nvPr/>
+        </p:nvPicPr>
+        <p:blipFill>
+          <a:blip r:embed="rId2"/>
+          <a:stretch>
+            <a:fillRect/>
+          </a:stretch>
+        </p:blipFill>
+        <p:spPr>
+          <a:xfrm>
+            <a:off x="0" y="0"/>
+            <a:ext cx="12191695" cy="6858000"/>
+          </a:xfrm>
+          <a:prstGeom prst="rect">
+            <a:avLst/>
+          </a:prstGeom>
+        </p:spPr>
+      </p:pic>
+      <p:sp>
+        <p:nvSpPr>
+          <p:cNvPr id="3" name="Rectangle 2"/>
           <p:cNvSpPr/>
           <p:nvPr/>
         </p:nvSpPr>
         <p:spPr>
           <a:xfrm>
             <a:off x="0" y="0"/>
-            <a:ext cx="12191695" cy="6858000"/>
-          </a:xfrm>
-          <a:prstGeom prst="rect">
-            <a:avLst/>
-          </a:prstGeom>
-          <a:solidFill>
-            <a:srgbClr val="0E0E11"/>
-          </a:solidFill>
-          <a:ln>
-            <a:noFill/>
-          </a:ln>
-        </p:spPr>
-        <p:style>
-          <a:lnRef idx="1">
-            <a:schemeClr val="accent1"/>
-          </a:lnRef>
-          <a:fillRef idx="3">
-            <a:schemeClr val="accent1"/>
-          </a:fillRef>
-          <a:effectRef idx="2">
-            <a:schemeClr val="accent1"/>
-          </a:effectRef>
-          <a:fontRef idx="minor">
-            <a:schemeClr val="lt1"/>
-          </a:fontRef>
-        </p:style>
-        <p:txBody>
-          <a:bodyPr rtlCol="0" anchor="ctr"/>
-          <a:lstStyle/>
-          <a:p>
-            <a:pPr algn="ctr"/>
-          </a:p>
-        </p:txBody>
-      </p:sp>
-      <p:sp>
-        <p:nvSpPr>
-          <p:cNvPr id="3" name="Right Triangle 2"/>
-          <p:cNvSpPr/>
-          <p:nvPr/>
-        </p:nvSpPr>
-        <p:spPr>
-          <a:xfrm rot="10800000">
-            <a:off x="7772400" y="0"/>
-            <a:ext cx="4419295" cy="6858000"/>
-          </a:xfrm>
-          <a:prstGeom prst="rtTriangle">
+            <a:ext cx="12191695" cy="109728"/>
+          </a:xfrm>
+          <a:prstGeom prst="rect">
             <a:avLst/>
           </a:prstGeom>
           <a:solidFill>
@@ -3183,57 +3164,14 @@
       </p:sp>
       <p:sp>
         <p:nvSpPr>
-          <p:cNvPr id="4" name="Right Triangle 3"/>
+          <p:cNvPr id="4" name="Rectangle 3"/>
           <p:cNvSpPr/>
           <p:nvPr/>
         </p:nvSpPr>
         <p:spPr>
-          <a:xfrm rot="10800000">
-            <a:off x="9601200" y="0"/>
-            <a:ext cx="2590495" cy="6858000"/>
-          </a:xfrm>
-          <a:prstGeom prst="rtTriangle">
-            <a:avLst/>
-          </a:prstGeom>
-          <a:solidFill>
-            <a:srgbClr val="A3000C"/>
-          </a:solidFill>
-          <a:ln>
-            <a:noFill/>
-          </a:ln>
-        </p:spPr>
-        <p:style>
-          <a:lnRef idx="1">
-            <a:schemeClr val="accent1"/>
-          </a:lnRef>
-          <a:fillRef idx="3">
-            <a:schemeClr val="accent1"/>
-          </a:fillRef>
-          <a:effectRef idx="2">
-            <a:schemeClr val="accent1"/>
-          </a:effectRef>
-          <a:fontRef idx="minor">
-            <a:schemeClr val="lt1"/>
-          </a:fontRef>
-        </p:style>
-        <p:txBody>
-          <a:bodyPr rtlCol="0" anchor="ctr"/>
-          <a:lstStyle/>
-          <a:p>
-            <a:pPr algn="ctr"/>
-          </a:p>
-        </p:txBody>
-      </p:sp>
-      <p:sp>
-        <p:nvSpPr>
-          <p:cNvPr id="5" name="Rectangle 4"/>
-          <p:cNvSpPr/>
-          <p:nvPr/>
-        </p:nvSpPr>
-        <p:spPr>
-          <a:xfrm>
-            <a:off x="731520" y="731520"/>
-            <a:ext cx="3108960" cy="384048"/>
+          <a:xfrm>
+            <a:off x="731520" y="640080"/>
+            <a:ext cx="3291840" cy="384048"/>
           </a:xfrm>
           <a:prstGeom prst="rect">
             <a:avLst/>
@@ -3277,58 +3215,46 @@
           </a:p>
         </p:txBody>
       </p:sp>
-      <p:sp>
-        <p:nvSpPr>
-          <p:cNvPr id="6" name="TextBox 5"/>
-          <p:cNvSpPr txBox="1"/>
+      <p:pic>
+        <p:nvPicPr>
+          <p:cNvPr id="5" name="Picture 4" descr="title_1.png"/>
+          <p:cNvPicPr>
+            <a:picLocks noChangeAspect="1"/>
+          </p:cNvPicPr>
           <p:nvPr/>
-        </p:nvSpPr>
-        <p:spPr>
-          <a:xfrm>
-            <a:off x="685800" y="1280160"/>
-            <a:ext cx="7772400" cy="1645920"/>
-          </a:xfrm>
-          <a:prstGeom prst="rect">
-            <a:avLst/>
-          </a:prstGeom>
-          <a:noFill/>
-        </p:spPr>
-        <p:txBody>
-          <a:bodyPr wrap="square">
-            <a:spAutoFit/>
-          </a:bodyPr>
-          <a:lstStyle/>
-          <a:p>
-            <a:pPr>
-              <a:defRPr sz="5000" b="1">
-                <a:solidFill>
-                  <a:srgbClr val="F6F4EF"/>
-                </a:solidFill>
-                <a:latin typeface="Arial Black"/>
-              </a:defRPr>
-            </a:pPr>
-            <a:r>
-              <a:t>SANZ GOKU</a:t>
-            </a:r>
-          </a:p>
-        </p:txBody>
-      </p:sp>
-      <p:sp>
-        <p:nvSpPr>
-          <p:cNvPr id="7" name="Rectangle 6"/>
+        </p:nvPicPr>
+        <p:blipFill>
+          <a:blip r:embed="rId3"/>
+          <a:stretch>
+            <a:fillRect/>
+          </a:stretch>
+        </p:blipFill>
+        <p:spPr>
+          <a:xfrm>
+            <a:off x="713232" y="1188720"/>
+            <a:ext cx="6963664" cy="1051560"/>
+          </a:xfrm>
+          <a:prstGeom prst="rect">
+            <a:avLst/>
+          </a:prstGeom>
+        </p:spPr>
+      </p:pic>
+      <p:sp>
+        <p:nvSpPr>
+          <p:cNvPr id="6" name="Rectangle 5"/>
           <p:cNvSpPr/>
           <p:nvPr/>
         </p:nvSpPr>
         <p:spPr>
           <a:xfrm>
-            <a:off x="731520" y="2926080"/>
-            <a:ext cx="5303520" cy="502920"/>
+            <a:off x="731520" y="2468880"/>
+            <a:ext cx="5303520" cy="530352"/>
           </a:xfrm>
           <a:prstGeom prst="rect">
             <a:avLst/>
           </a:prstGeom>
           <a:solidFill>
-            <a:srgbClr val="1A1A20"/>
+            <a:srgbClr val="0F0F14"/>
           </a:solidFill>
           <a:ln w="19050">
             <a:solidFill>
@@ -3351,7 +3277,7 @@
           </a:fontRef>
         </p:style>
         <p:txBody>
-          <a:bodyPr rtlCol="0" anchor="ctr"/>
+          <a:bodyPr rtlCol="0" anchor="ctr" tIns="109728"/>
           <a:lstStyle/>
           <a:p>
             <a:pPr algn="ctr">
@@ -3370,56 +3296,75 @@
       </p:sp>
       <p:sp>
         <p:nvSpPr>
-          <p:cNvPr id="8" name="TextBox 7"/>
-          <p:cNvSpPr txBox="1"/>
-          <p:nvPr/>
-        </p:nvSpPr>
-        <p:spPr>
-          <a:xfrm>
-            <a:off x="685800" y="3611880"/>
-            <a:ext cx="6858000" cy="1097280"/>
-          </a:xfrm>
-          <a:prstGeom prst="rect">
-            <a:avLst/>
-          </a:prstGeom>
-          <a:noFill/>
-        </p:spPr>
-        <p:txBody>
-          <a:bodyPr wrap="square">
-            <a:spAutoFit/>
-          </a:bodyPr>
-          <a:lstStyle/>
-          <a:p>
-            <a:pPr>
-              <a:defRPr sz="1300">
-                <a:solidFill>
-                  <a:srgbClr val="F6F4EF"/>
-                </a:solidFill>
-                <a:latin typeface="Arial"/>
-              </a:defRPr>
-            </a:pPr>
-            <a:r>
-              <a:t>Penyedia produk &amp; layanan digital, infrastruktur server Linux, panel Pterodactyl, nomor virtual OTP, serta solusi otomatisasi transaksi berbasis bot Telegram (@Sanzstrnokosmumerbot).</a:t>
-            </a:r>
-          </a:p>
-        </p:txBody>
-      </p:sp>
-      <p:sp>
-        <p:nvSpPr>
-          <p:cNvPr id="9" name="Rectangle 8"/>
+          <p:cNvPr id="7" name="Rectangle 6"/>
           <p:cNvSpPr/>
           <p:nvPr/>
         </p:nvSpPr>
         <p:spPr>
           <a:xfrm>
+            <a:off x="731520" y="3200400"/>
+            <a:ext cx="6949440" cy="1463040"/>
+          </a:xfrm>
+          <a:prstGeom prst="rect">
+            <a:avLst/>
+          </a:prstGeom>
+          <a:solidFill>
+            <a:srgbClr val="0F0F14"/>
+          </a:solidFill>
+          <a:ln w="12700">
+            <a:solidFill>
+              <a:srgbClr val="3C3C48"/>
+            </a:solidFill>
+          </a:ln>
+        </p:spPr>
+        <p:style>
+          <a:lnRef idx="1">
+            <a:schemeClr val="accent1"/>
+          </a:lnRef>
+          <a:fillRef idx="3">
+            <a:schemeClr val="accent1"/>
+          </a:fillRef>
+          <a:effectRef idx="2">
+            <a:schemeClr val="accent1"/>
+          </a:effectRef>
+          <a:fontRef idx="minor">
+            <a:schemeClr val="lt1"/>
+          </a:fontRef>
+        </p:style>
+        <p:txBody>
+          <a:bodyPr rtlCol="0" anchor="ctr" wrap="square" lIns="228600" tIns="182880"/>
+          <a:lstStyle/>
+          <a:p>
+            <a:pPr algn="ctr">
+              <a:defRPr sz="1350">
+                <a:solidFill>
+                  <a:srgbClr val="F6F4EF"/>
+                </a:solidFill>
+                <a:latin typeface="Arial"/>
+              </a:defRPr>
+            </a:pPr>
+            <a:r>
+              <a:t>Penyedia produk &amp; layanan digital, infrastruktur server Linux, panel Pterodactyl, nomor virtual OTP, serta solusi otomatisasi transaksi berbasis bot Telegram (@Sanzstrnokosmumerbot).</a:t>
+            </a:r>
+          </a:p>
+        </p:txBody>
+      </p:sp>
+      <p:sp>
+        <p:nvSpPr>
+          <p:cNvPr id="8" name="Rectangle 7"/>
+          <p:cNvSpPr/>
+          <p:nvPr/>
+        </p:nvSpPr>
+        <p:spPr>
+          <a:xfrm>
             <a:off x="731520" y="4846320"/>
-            <a:ext cx="6583680" cy="1280160"/>
+            <a:ext cx="6949440" cy="1325880"/>
           </a:xfrm>
           <a:prstGeom prst="rect">
             <a:avLst/>
           </a:prstGeom>
           <a:solidFill>
-            <a:srgbClr val="1A1A20"/>
+            <a:srgbClr val="0F0F14"/>
           </a:solidFill>
           <a:ln w="25400">
             <a:solidFill>
@@ -3474,7 +3419,7 @@
             <a:pPr>
               <a:defRPr sz="1100">
                 <a:solidFill>
-                  <a:srgbClr val="AAAAB4"/>
+                  <a:srgbClr val="AFAFBE"/>
                 </a:solidFill>
                 <a:latin typeface="Arial"/>
               </a:defRPr>
@@ -3487,7 +3432,7 @@
       </p:sp>
       <p:sp>
         <p:nvSpPr>
-          <p:cNvPr id="10" name="TextBox 9"/>
+          <p:cNvPr id="9" name="TextBox 8"/>
           <p:cNvSpPr txBox="1"/>
           <p:nvPr/>
         </p:nvSpPr>
@@ -3510,7 +3455,7 @@
             <a:pPr>
               <a:defRPr sz="1000">
                 <a:solidFill>
-                  <a:srgbClr val="AAAAB4"/>
+                  <a:srgbClr val="AFAFBE"/>
                 </a:solidFill>
                 <a:latin typeface="Arial"/>
               </a:defRPr>
@@ -3539,310 +3484,9 @@
         <p:nvPr/>
       </p:nvGrpSpPr>
       <p:grpSpPr/>
-      <p:sp>
-        <p:nvSpPr>
-          <p:cNvPr id="2" name="Rectangle 1"/>
-          <p:cNvSpPr/>
-          <p:nvPr/>
-        </p:nvSpPr>
-        <p:spPr>
-          <a:xfrm>
-            <a:off x="0" y="0"/>
-            <a:ext cx="12191695" cy="6858000"/>
-          </a:xfrm>
-          <a:prstGeom prst="rect">
-            <a:avLst/>
-          </a:prstGeom>
-          <a:solidFill>
-            <a:srgbClr val="0E0E11"/>
-          </a:solidFill>
-          <a:ln>
-            <a:noFill/>
-          </a:ln>
-        </p:spPr>
-        <p:style>
-          <a:lnRef idx="1">
-            <a:schemeClr val="accent1"/>
-          </a:lnRef>
-          <a:fillRef idx="3">
-            <a:schemeClr val="accent1"/>
-          </a:fillRef>
-          <a:effectRef idx="2">
-            <a:schemeClr val="accent1"/>
-          </a:effectRef>
-          <a:fontRef idx="minor">
-            <a:schemeClr val="lt1"/>
-          </a:fontRef>
-        </p:style>
-        <p:txBody>
-          <a:bodyPr rtlCol="0" anchor="ctr"/>
-          <a:lstStyle/>
-          <a:p>
-            <a:pPr algn="ctr"/>
-          </a:p>
-        </p:txBody>
-      </p:sp>
-      <p:sp>
-        <p:nvSpPr>
-          <p:cNvPr id="3" name="Rectangle 2"/>
-          <p:cNvSpPr/>
-          <p:nvPr/>
-        </p:nvSpPr>
-        <p:spPr>
-          <a:xfrm>
-            <a:off x="0" y="0"/>
-            <a:ext cx="12191695" cy="109728"/>
-          </a:xfrm>
-          <a:prstGeom prst="rect">
-            <a:avLst/>
-          </a:prstGeom>
-          <a:solidFill>
-            <a:srgbClr val="E60012"/>
-          </a:solidFill>
-          <a:ln>
-            <a:noFill/>
-          </a:ln>
-        </p:spPr>
-        <p:style>
-          <a:lnRef idx="1">
-            <a:schemeClr val="accent1"/>
-          </a:lnRef>
-          <a:fillRef idx="3">
-            <a:schemeClr val="accent1"/>
-          </a:fillRef>
-          <a:effectRef idx="2">
-            <a:schemeClr val="accent1"/>
-          </a:effectRef>
-          <a:fontRef idx="minor">
-            <a:schemeClr val="lt1"/>
-          </a:fontRef>
-        </p:style>
-        <p:txBody>
-          <a:bodyPr rtlCol="0" anchor="ctr"/>
-          <a:lstStyle/>
-          <a:p>
-            <a:pPr algn="ctr"/>
-          </a:p>
-        </p:txBody>
-      </p:sp>
-      <p:sp>
-        <p:nvSpPr>
-          <p:cNvPr id="4" name="Rectangle 3"/>
-          <p:cNvSpPr/>
-          <p:nvPr/>
-        </p:nvSpPr>
-        <p:spPr>
-          <a:xfrm>
-            <a:off x="731520" y="365760"/>
-            <a:ext cx="2560320" cy="347472"/>
-          </a:xfrm>
-          <a:prstGeom prst="rect">
-            <a:avLst/>
-          </a:prstGeom>
-          <a:solidFill>
-            <a:srgbClr val="E60012"/>
-          </a:solidFill>
-          <a:ln>
-            <a:noFill/>
-          </a:ln>
-        </p:spPr>
-        <p:style>
-          <a:lnRef idx="1">
-            <a:schemeClr val="accent1"/>
-          </a:lnRef>
-          <a:fillRef idx="3">
-            <a:schemeClr val="accent1"/>
-          </a:fillRef>
-          <a:effectRef idx="2">
-            <a:schemeClr val="accent1"/>
-          </a:effectRef>
-          <a:fontRef idx="minor">
-            <a:schemeClr val="lt1"/>
-          </a:fontRef>
-        </p:style>
-        <p:txBody>
-          <a:bodyPr rtlCol="0" anchor="ctr" wrap="square" tIns="36576"/>
-          <a:lstStyle/>
-          <a:p>
-            <a:pPr algn="ctr">
-              <a:defRPr sz="1100" b="1">
-                <a:solidFill>
-                  <a:srgbClr val="F6F4EF"/>
-                </a:solidFill>
-                <a:latin typeface="Arial Black"/>
-              </a:defRPr>
-            </a:pPr>
-            <a:r>
-              <a:t>02 // IDENTITAS &amp; NILAI</a:t>
-            </a:r>
-          </a:p>
-        </p:txBody>
-      </p:sp>
-      <p:sp>
-        <p:nvSpPr>
-          <p:cNvPr id="5" name="TextBox 4"/>
-          <p:cNvSpPr txBox="1"/>
-          <p:nvPr/>
-        </p:nvSpPr>
-        <p:spPr>
-          <a:xfrm>
-            <a:off x="685800" y="777240"/>
-            <a:ext cx="10789920" cy="640080"/>
-          </a:xfrm>
-          <a:prstGeom prst="rect">
-            <a:avLst/>
-          </a:prstGeom>
-          <a:noFill/>
-        </p:spPr>
-        <p:txBody>
-          <a:bodyPr wrap="square">
-            <a:spAutoFit/>
-          </a:bodyPr>
-          <a:lstStyle/>
-          <a:p>
-            <a:pPr>
-              <a:defRPr sz="2400" b="1">
-                <a:solidFill>
-                  <a:srgbClr val="F6F4EF"/>
-                </a:solidFill>
-                <a:latin typeface="Arial Black"/>
-              </a:defRPr>
-            </a:pPr>
-            <a:r>
-              <a:t>PROFIL SANZ GOKU</a:t>
-            </a:r>
-          </a:p>
-        </p:txBody>
-      </p:sp>
-      <p:sp>
-        <p:nvSpPr>
-          <p:cNvPr id="6" name="Rectangle 5"/>
-          <p:cNvSpPr/>
-          <p:nvPr/>
-        </p:nvSpPr>
-        <p:spPr>
-          <a:xfrm>
-            <a:off x="731520" y="1444752"/>
-            <a:ext cx="10728655" cy="27432"/>
-          </a:xfrm>
-          <a:prstGeom prst="rect">
-            <a:avLst/>
-          </a:prstGeom>
-          <a:solidFill>
-            <a:srgbClr val="A3000C"/>
-          </a:solidFill>
-          <a:ln>
-            <a:noFill/>
-          </a:ln>
-        </p:spPr>
-        <p:style>
-          <a:lnRef idx="1">
-            <a:schemeClr val="accent1"/>
-          </a:lnRef>
-          <a:fillRef idx="3">
-            <a:schemeClr val="accent1"/>
-          </a:fillRef>
-          <a:effectRef idx="2">
-            <a:schemeClr val="accent1"/>
-          </a:effectRef>
-          <a:fontRef idx="minor">
-            <a:schemeClr val="lt1"/>
-          </a:fontRef>
-        </p:style>
-        <p:txBody>
-          <a:bodyPr rtlCol="0" anchor="ctr"/>
-          <a:lstStyle/>
-          <a:p>
-            <a:pPr algn="ctr"/>
-          </a:p>
-        </p:txBody>
-      </p:sp>
-      <p:sp>
-        <p:nvSpPr>
-          <p:cNvPr id="7" name="Rectangle 6"/>
-          <p:cNvSpPr/>
-          <p:nvPr/>
-        </p:nvSpPr>
-        <p:spPr>
-          <a:xfrm>
-            <a:off x="731520" y="1645920"/>
-            <a:ext cx="2651760" cy="4526280"/>
-          </a:xfrm>
-          <a:prstGeom prst="rect">
-            <a:avLst/>
-          </a:prstGeom>
-          <a:solidFill>
-            <a:srgbClr val="F6F4EF"/>
-          </a:solidFill>
-          <a:ln w="25400">
-            <a:solidFill>
-              <a:srgbClr val="E60012"/>
-            </a:solidFill>
-          </a:ln>
-        </p:spPr>
-        <p:style>
-          <a:lnRef idx="1">
-            <a:schemeClr val="accent1"/>
-          </a:lnRef>
-          <a:fillRef idx="3">
-            <a:schemeClr val="accent1"/>
-          </a:fillRef>
-          <a:effectRef idx="2">
-            <a:schemeClr val="accent1"/>
-          </a:effectRef>
-          <a:fontRef idx="minor">
-            <a:schemeClr val="lt1"/>
-          </a:fontRef>
-        </p:style>
-        <p:txBody>
-          <a:bodyPr rtlCol="0" anchor="ctr" lIns="137160" rIns="137160" tIns="2651760"/>
-          <a:lstStyle/>
-          <a:p>
-            <a:pPr algn="ctr">
-              <a:defRPr sz="1000" b="1">
-                <a:solidFill>
-                  <a:srgbClr val="111111"/>
-                </a:solidFill>
-                <a:latin typeface="Arial Black"/>
-              </a:defRPr>
-            </a:pPr>
-            <a:r>
-              <a:t>MUHAMMAD SANDIKA AKBAR</a:t>
-            </a:r>
-          </a:p>
-          <a:p>
-            <a:pPr>
-              <a:spcBef>
-                <a:spcPts val="400"/>
-              </a:spcBef>
-              <a:defRPr sz="950">
-                <a:solidFill>
-                  <a:srgbClr val="3C3C3C"/>
-                </a:solidFill>
-                <a:latin typeface="Arial"/>
-              </a:defRPr>
-            </a:pPr>
-            <a:r>
-              <a:t>Founder / Owner (Sanz)</a:t>
-            </a:r>
-            <a:br/>
-            <a:r>
-              <a:t>Domain: snz.web.id</a:t>
-            </a:r>
-            <a:br/>
-            <a:r>
-              <a:t>Bot: @Sanzstrnokosmumerbot</a:t>
-            </a:r>
-            <a:br/>
-            <a:r>
-              <a:t>Admin: @Sanzxgoku</a:t>
-            </a:r>
-          </a:p>
-        </p:txBody>
-      </p:sp>
       <p:pic>
         <p:nvPicPr>
-          <p:cNvPr id="8" name="Picture 7" descr="me.jpg"/>
+          <p:cNvPr id="2" name="Picture 1" descr="bg_slide2.jpg"/>
           <p:cNvPicPr>
             <a:picLocks noChangeAspect="1"/>
           </p:cNvPicPr>
@@ -3856,8 +3500,8 @@
         </p:blipFill>
         <p:spPr>
           <a:xfrm>
-            <a:off x="868680" y="1783080"/>
-            <a:ext cx="2377440" cy="2377440"/>
+            <a:off x="0" y="0"/>
+            <a:ext cx="12191695" cy="6858000"/>
           </a:xfrm>
           <a:prstGeom prst="rect">
             <a:avLst/>
@@ -3866,20 +3510,207 @@
       </p:pic>
       <p:sp>
         <p:nvSpPr>
-          <p:cNvPr id="9" name="Rectangle 8"/>
+          <p:cNvPr id="3" name="Rectangle 2"/>
           <p:cNvSpPr/>
           <p:nvPr/>
         </p:nvSpPr>
         <p:spPr>
           <a:xfrm>
-            <a:off x="3566160" y="1645920"/>
-            <a:ext cx="7894015" cy="1188720"/>
+            <a:off x="0" y="0"/>
+            <a:ext cx="12191695" cy="109728"/>
           </a:xfrm>
           <a:prstGeom prst="rect">
             <a:avLst/>
           </a:prstGeom>
           <a:solidFill>
-            <a:srgbClr val="1A1A20"/>
+            <a:srgbClr val="E60012"/>
+          </a:solidFill>
+          <a:ln>
+            <a:noFill/>
+          </a:ln>
+        </p:spPr>
+        <p:style>
+          <a:lnRef idx="1">
+            <a:schemeClr val="accent1"/>
+          </a:lnRef>
+          <a:fillRef idx="3">
+            <a:schemeClr val="accent1"/>
+          </a:fillRef>
+          <a:effectRef idx="2">
+            <a:schemeClr val="accent1"/>
+          </a:effectRef>
+          <a:fontRef idx="minor">
+            <a:schemeClr val="lt1"/>
+          </a:fontRef>
+        </p:style>
+        <p:txBody>
+          <a:bodyPr rtlCol="0" anchor="ctr"/>
+          <a:lstStyle/>
+          <a:p>
+            <a:pPr algn="ctr"/>
+          </a:p>
+        </p:txBody>
+      </p:sp>
+      <p:sp>
+        <p:nvSpPr>
+          <p:cNvPr id="4" name="Rectangle 3"/>
+          <p:cNvSpPr/>
+          <p:nvPr/>
+        </p:nvSpPr>
+        <p:spPr>
+          <a:xfrm>
+            <a:off x="731520" y="320040"/>
+            <a:ext cx="2926080" cy="329184"/>
+          </a:xfrm>
+          <a:prstGeom prst="rect">
+            <a:avLst/>
+          </a:prstGeom>
+          <a:solidFill>
+            <a:srgbClr val="E60012"/>
+          </a:solidFill>
+          <a:ln>
+            <a:noFill/>
+          </a:ln>
+        </p:spPr>
+        <p:style>
+          <a:lnRef idx="1">
+            <a:schemeClr val="accent1"/>
+          </a:lnRef>
+          <a:fillRef idx="3">
+            <a:schemeClr val="accent1"/>
+          </a:fillRef>
+          <a:effectRef idx="2">
+            <a:schemeClr val="accent1"/>
+          </a:effectRef>
+          <a:fontRef idx="minor">
+            <a:schemeClr val="lt1"/>
+          </a:fontRef>
+        </p:style>
+        <p:txBody>
+          <a:bodyPr rtlCol="0" anchor="ctr" wrap="square" lIns="109728" tIns="36576"/>
+          <a:lstStyle/>
+          <a:p>
+            <a:pPr algn="ctr">
+              <a:defRPr sz="1100" b="1">
+                <a:solidFill>
+                  <a:srgbClr val="F6F4EF"/>
+                </a:solidFill>
+                <a:latin typeface="Arial Black"/>
+              </a:defRPr>
+            </a:pPr>
+            <a:r>
+              <a:t>02 // IDENTITAS &amp; NILAI</a:t>
+            </a:r>
+          </a:p>
+        </p:txBody>
+      </p:sp>
+      <p:pic>
+        <p:nvPicPr>
+          <p:cNvPr id="5" name="Picture 4" descr="title_2.png"/>
+          <p:cNvPicPr>
+            <a:picLocks noChangeAspect="1"/>
+          </p:cNvPicPr>
+          <p:nvPr/>
+        </p:nvPicPr>
+        <p:blipFill>
+          <a:blip r:embed="rId3"/>
+          <a:stretch>
+            <a:fillRect/>
+          </a:stretch>
+        </p:blipFill>
+        <p:spPr>
+          <a:xfrm>
+            <a:off x="713232" y="694944"/>
+            <a:ext cx="6226173" cy="566928"/>
+          </a:xfrm>
+          <a:prstGeom prst="rect">
+            <a:avLst/>
+          </a:prstGeom>
+        </p:spPr>
+      </p:pic>
+      <p:sp>
+        <p:nvSpPr>
+          <p:cNvPr id="6" name="Rectangle 5"/>
+          <p:cNvSpPr/>
+          <p:nvPr/>
+        </p:nvSpPr>
+        <p:spPr>
+          <a:xfrm>
+            <a:off x="731520" y="1353312"/>
+            <a:ext cx="10728655" cy="27432"/>
+          </a:xfrm>
+          <a:prstGeom prst="rect">
+            <a:avLst/>
+          </a:prstGeom>
+          <a:solidFill>
+            <a:srgbClr val="E60012"/>
+          </a:solidFill>
+          <a:ln>
+            <a:noFill/>
+          </a:ln>
+        </p:spPr>
+        <p:style>
+          <a:lnRef idx="1">
+            <a:schemeClr val="accent1"/>
+          </a:lnRef>
+          <a:fillRef idx="3">
+            <a:schemeClr val="accent1"/>
+          </a:fillRef>
+          <a:effectRef idx="2">
+            <a:schemeClr val="accent1"/>
+          </a:effectRef>
+          <a:fontRef idx="minor">
+            <a:schemeClr val="lt1"/>
+          </a:fontRef>
+        </p:style>
+        <p:txBody>
+          <a:bodyPr rtlCol="0" anchor="ctr"/>
+          <a:lstStyle/>
+          <a:p>
+            <a:pPr algn="ctr"/>
+          </a:p>
+        </p:txBody>
+      </p:sp>
+      <p:pic>
+        <p:nvPicPr>
+          <p:cNvPr id="7" name="Picture 6" descr="polaroid_me.png"/>
+          <p:cNvPicPr>
+            <a:picLocks noChangeAspect="1"/>
+          </p:cNvPicPr>
+          <p:nvPr/>
+        </p:nvPicPr>
+        <p:blipFill>
+          <a:blip r:embed="rId4"/>
+          <a:stretch>
+            <a:fillRect/>
+          </a:stretch>
+        </p:blipFill>
+        <p:spPr>
+          <a:xfrm>
+            <a:off x="640080" y="1554480"/>
+            <a:ext cx="3291840" cy="4083548"/>
+          </a:xfrm>
+          <a:prstGeom prst="rect">
+            <a:avLst/>
+          </a:prstGeom>
+        </p:spPr>
+      </p:pic>
+      <p:sp>
+        <p:nvSpPr>
+          <p:cNvPr id="8" name="Rectangle 7"/>
+          <p:cNvSpPr/>
+          <p:nvPr/>
+        </p:nvSpPr>
+        <p:spPr>
+          <a:xfrm>
+            <a:off x="4114800" y="1554480"/>
+            <a:ext cx="7345375" cy="1234440"/>
+          </a:xfrm>
+          <a:prstGeom prst="rect">
+            <a:avLst/>
+          </a:prstGeom>
+          <a:solidFill>
+            <a:srgbClr val="0F0F14"/>
           </a:solidFill>
           <a:ln w="19050">
             <a:solidFill>
@@ -3906,21 +3737,21 @@
           <a:lstStyle/>
           <a:p>
             <a:pPr algn="ctr">
+              <a:defRPr sz="1100" b="1">
+                <a:solidFill>
+                  <a:srgbClr val="F1E05A"/>
+                </a:solidFill>
+                <a:latin typeface="Arial Black"/>
+              </a:defRPr>
+            </a:pPr>
+            <a:r>
+              <a:t>★ RINGKASAN EKSEKUTIF</a:t>
+            </a:r>
+          </a:p>
+          <a:p>
+            <a:pPr>
               <a:defRPr sz="1100">
                 <a:solidFill>
-                  <a:srgbClr val="F1E05A"/>
-                </a:solidFill>
-                <a:latin typeface="Arial Black"/>
-              </a:defRPr>
-            </a:pPr>
-            <a:r>
-              <a:t>RINGKASAN EKSEKUTIF</a:t>
-            </a:r>
-          </a:p>
-          <a:p>
-            <a:pPr>
-              <a:defRPr sz="1100">
-                <a:solidFill>
                   <a:srgbClr val="F6F4EF"/>
                 </a:solidFill>
                 <a:latin typeface="Arial"/>
@@ -3934,24 +3765,24 @@
       </p:sp>
       <p:sp>
         <p:nvSpPr>
-          <p:cNvPr id="10" name="Rectangle 9"/>
+          <p:cNvPr id="9" name="Rectangle 8"/>
           <p:cNvSpPr/>
           <p:nvPr/>
         </p:nvSpPr>
         <p:spPr>
           <a:xfrm>
-            <a:off x="3566160" y="3017520"/>
-            <a:ext cx="3870655" cy="1536192"/>
+            <a:off x="4114800" y="2971800"/>
+            <a:ext cx="3596335" cy="1572768"/>
           </a:xfrm>
           <a:prstGeom prst="rect">
             <a:avLst/>
           </a:prstGeom>
           <a:solidFill>
-            <a:srgbClr val="1A1A20"/>
+            <a:srgbClr val="0F0F14"/>
           </a:solidFill>
           <a:ln w="12700">
             <a:solidFill>
-              <a:srgbClr val="3C3C46"/>
+              <a:srgbClr val="3C3C48"/>
             </a:solidFill>
           </a:ln>
         </p:spPr>
@@ -4041,24 +3872,24 @@
       </p:sp>
       <p:sp>
         <p:nvSpPr>
-          <p:cNvPr id="11" name="Rectangle 10"/>
+          <p:cNvPr id="10" name="Rectangle 9"/>
           <p:cNvSpPr/>
           <p:nvPr/>
         </p:nvSpPr>
         <p:spPr>
           <a:xfrm>
-            <a:off x="7589520" y="3017520"/>
-            <a:ext cx="3870655" cy="1536192"/>
+            <a:off x="7863840" y="2971800"/>
+            <a:ext cx="3596335" cy="1572768"/>
           </a:xfrm>
           <a:prstGeom prst="rect">
             <a:avLst/>
           </a:prstGeom>
           <a:solidFill>
-            <a:srgbClr val="1A1A20"/>
+            <a:srgbClr val="0F0F14"/>
           </a:solidFill>
           <a:ln w="12700">
             <a:solidFill>
-              <a:srgbClr val="3C3C46"/>
+              <a:srgbClr val="3C3C48"/>
             </a:solidFill>
           </a:ln>
         </p:spPr>
@@ -4148,24 +3979,24 @@
       </p:sp>
       <p:sp>
         <p:nvSpPr>
-          <p:cNvPr id="12" name="Rectangle 11"/>
+          <p:cNvPr id="11" name="Rectangle 10"/>
           <p:cNvSpPr/>
           <p:nvPr/>
         </p:nvSpPr>
         <p:spPr>
           <a:xfrm>
-            <a:off x="3566160" y="4709160"/>
-            <a:ext cx="3870655" cy="1536192"/>
+            <a:off x="4114800" y="4663440"/>
+            <a:ext cx="3596335" cy="1572768"/>
           </a:xfrm>
           <a:prstGeom prst="rect">
             <a:avLst/>
           </a:prstGeom>
           <a:solidFill>
-            <a:srgbClr val="1A1A20"/>
+            <a:srgbClr val="0F0F14"/>
           </a:solidFill>
           <a:ln w="12700">
             <a:solidFill>
-              <a:srgbClr val="3C3C46"/>
+              <a:srgbClr val="3C3C48"/>
             </a:solidFill>
           </a:ln>
         </p:spPr>
@@ -4255,24 +4086,24 @@
       </p:sp>
       <p:sp>
         <p:nvSpPr>
-          <p:cNvPr id="13" name="Rectangle 12"/>
+          <p:cNvPr id="12" name="Rectangle 11"/>
           <p:cNvSpPr/>
           <p:nvPr/>
         </p:nvSpPr>
         <p:spPr>
           <a:xfrm>
-            <a:off x="7589520" y="4709160"/>
-            <a:ext cx="3870655" cy="1536192"/>
+            <a:off x="7863840" y="4663440"/>
+            <a:ext cx="3596335" cy="1572768"/>
           </a:xfrm>
           <a:prstGeom prst="rect">
             <a:avLst/>
           </a:prstGeom>
           <a:solidFill>
-            <a:srgbClr val="1A1A20"/>
+            <a:srgbClr val="0F0F14"/>
           </a:solidFill>
           <a:ln w="12700">
             <a:solidFill>
-              <a:srgbClr val="3C3C46"/>
+              <a:srgbClr val="3C3C48"/>
             </a:solidFill>
           </a:ln>
         </p:spPr>
@@ -4362,7 +4193,7 @@
       </p:sp>
       <p:sp>
         <p:nvSpPr>
-          <p:cNvPr id="14" name="TextBox 13"/>
+          <p:cNvPr id="13" name="TextBox 12"/>
           <p:cNvSpPr txBox="1"/>
           <p:nvPr/>
         </p:nvSpPr>
@@ -4385,7 +4216,7 @@
             <a:pPr>
               <a:defRPr sz="1000">
                 <a:solidFill>
-                  <a:srgbClr val="AAAAB4"/>
+                  <a:srgbClr val="AFAFBE"/>
                 </a:solidFill>
                 <a:latin typeface="Arial"/>
               </a:defRPr>
@@ -4414,12 +4245,20 @@
         <p:nvPr/>
       </p:nvGrpSpPr>
       <p:grpSpPr/>
-      <p:sp>
-        <p:nvSpPr>
-          <p:cNvPr id="2" name="Rectangle 1"/>
-          <p:cNvSpPr/>
+      <p:pic>
+        <p:nvPicPr>
+          <p:cNvPr id="2" name="Picture 1" descr="bg_stripes.jpg"/>
+          <p:cNvPicPr>
+            <a:picLocks noChangeAspect="1"/>
+          </p:cNvPicPr>
           <p:nvPr/>
-        </p:nvSpPr>
+        </p:nvPicPr>
+        <p:blipFill>
+          <a:blip r:embed="rId2"/>
+          <a:stretch>
+            <a:fillRect/>
+          </a:stretch>
+        </p:blipFill>
         <p:spPr>
           <a:xfrm>
             <a:off x="0" y="0"/>
@@ -4428,35 +4267,8 @@
           <a:prstGeom prst="rect">
             <a:avLst/>
           </a:prstGeom>
-          <a:solidFill>
-            <a:srgbClr val="0E0E11"/>
-          </a:solidFill>
-          <a:ln>
-            <a:noFill/>
-          </a:ln>
-        </p:spPr>
-        <p:style>
-          <a:lnRef idx="1">
-            <a:schemeClr val="accent1"/>
-          </a:lnRef>
-          <a:fillRef idx="3">
-            <a:schemeClr val="accent1"/>
-          </a:fillRef>
-          <a:effectRef idx="2">
-            <a:schemeClr val="accent1"/>
-          </a:effectRef>
-          <a:fontRef idx="minor">
-            <a:schemeClr val="lt1"/>
-          </a:fontRef>
-        </p:style>
-        <p:txBody>
-          <a:bodyPr rtlCol="0" anchor="ctr"/>
-          <a:lstStyle/>
-          <a:p>
-            <a:pPr algn="ctr"/>
-          </a:p>
-        </p:txBody>
-      </p:sp>
+        </p:spPr>
+      </p:pic>
       <p:sp>
         <p:nvSpPr>
           <p:cNvPr id="3" name="Rectangle 2"/>
@@ -4508,8 +4320,8 @@
         </p:nvSpPr>
         <p:spPr>
           <a:xfrm>
-            <a:off x="731520" y="365760"/>
-            <a:ext cx="2560320" cy="347472"/>
+            <a:off x="731520" y="320040"/>
+            <a:ext cx="2926080" cy="329184"/>
           </a:xfrm>
           <a:prstGeom prst="rect">
             <a:avLst/>
@@ -4536,7 +4348,7 @@
           </a:fontRef>
         </p:style>
         <p:txBody>
-          <a:bodyPr rtlCol="0" anchor="ctr" wrap="square" tIns="36576"/>
+          <a:bodyPr rtlCol="0" anchor="ctr" wrap="square" lIns="109728" tIns="36576"/>
           <a:lstStyle/>
           <a:p>
             <a:pPr algn="ctr">
@@ -4553,42 +4365,30 @@
           </a:p>
         </p:txBody>
       </p:sp>
-      <p:sp>
-        <p:nvSpPr>
-          <p:cNvPr id="5" name="TextBox 4"/>
-          <p:cNvSpPr txBox="1"/>
+      <p:pic>
+        <p:nvPicPr>
+          <p:cNvPr id="5" name="Picture 4" descr="title_3.png"/>
+          <p:cNvPicPr>
+            <a:picLocks noChangeAspect="1"/>
+          </p:cNvPicPr>
           <p:nvPr/>
-        </p:nvSpPr>
-        <p:spPr>
-          <a:xfrm>
-            <a:off x="685800" y="777240"/>
-            <a:ext cx="10789920" cy="640080"/>
-          </a:xfrm>
-          <a:prstGeom prst="rect">
-            <a:avLst/>
-          </a:prstGeom>
-          <a:noFill/>
-        </p:spPr>
-        <p:txBody>
-          <a:bodyPr wrap="square">
-            <a:spAutoFit/>
-          </a:bodyPr>
-          <a:lstStyle/>
-          <a:p>
-            <a:pPr>
-              <a:defRPr sz="2400" b="1">
-                <a:solidFill>
-                  <a:srgbClr val="F6F4EF"/>
-                </a:solidFill>
-                <a:latin typeface="Arial Black"/>
-              </a:defRPr>
-            </a:pPr>
-            <a:r>
-              <a:t>PRODUK DAN LAYANAN</a:t>
-            </a:r>
-          </a:p>
-        </p:txBody>
-      </p:sp>
+        </p:nvPicPr>
+        <p:blipFill>
+          <a:blip r:embed="rId3"/>
+          <a:stretch>
+            <a:fillRect/>
+          </a:stretch>
+        </p:blipFill>
+        <p:spPr>
+          <a:xfrm>
+            <a:off x="713232" y="694944"/>
+            <a:ext cx="6361634" cy="566928"/>
+          </a:xfrm>
+          <a:prstGeom prst="rect">
+            <a:avLst/>
+          </a:prstGeom>
+        </p:spPr>
+      </p:pic>
       <p:sp>
         <p:nvSpPr>
           <p:cNvPr id="6" name="Rectangle 5"/>
@@ -4597,14 +4397,14 @@
         </p:nvSpPr>
         <p:spPr>
           <a:xfrm>
-            <a:off x="731520" y="1444752"/>
+            <a:off x="731520" y="1353312"/>
             <a:ext cx="10728655" cy="27432"/>
           </a:xfrm>
           <a:prstGeom prst="rect">
             <a:avLst/>
           </a:prstGeom>
           <a:solidFill>
-            <a:srgbClr val="A3000C"/>
+            <a:srgbClr val="E60012"/>
           </a:solidFill>
           <a:ln>
             <a:noFill/>
@@ -4640,14 +4440,14 @@
         </p:nvSpPr>
         <p:spPr>
           <a:xfrm>
-            <a:off x="731520" y="1645920"/>
+            <a:off x="731520" y="1554480"/>
             <a:ext cx="10728655" cy="384048"/>
           </a:xfrm>
           <a:prstGeom prst="rect">
             <a:avLst/>
           </a:prstGeom>
           <a:solidFill>
-            <a:srgbClr val="1A1A20"/>
+            <a:srgbClr val="0F0F14"/>
           </a:solidFill>
           <a:ln w="12700">
             <a:solidFill>
@@ -4682,7 +4482,7 @@
               </a:defRPr>
             </a:pPr>
             <a:r>
-              <a:t>CATATAN STATUS: Layanan dikelompokkan berdasarkan kategori. Membedakan layanan aktif berjualan vs tahap rencana/pengembangan.</a:t>
+              <a:t>★ CATATAN STATUS: Layanan dikelompokkan berdasarkan kategori. Membedakan layanan aktif berjualan vs tahap rencana/pengembangan.</a:t>
             </a:r>
           </a:p>
         </p:txBody>
@@ -4695,18 +4495,18 @@
         </p:nvSpPr>
         <p:spPr>
           <a:xfrm>
-            <a:off x="731520" y="2148840"/>
-            <a:ext cx="2542032" cy="4114800"/>
+            <a:off x="731520" y="2084831"/>
+            <a:ext cx="2542032" cy="4160520"/>
           </a:xfrm>
           <a:prstGeom prst="rect">
             <a:avLst/>
           </a:prstGeom>
           <a:solidFill>
-            <a:srgbClr val="1A1A20"/>
+            <a:srgbClr val="0F0F14"/>
           </a:solidFill>
-          <a:ln w="12700">
+          <a:ln w="19050">
             <a:solidFill>
-              <a:srgbClr val="3C3C46"/>
+              <a:srgbClr val="E60012"/>
             </a:solidFill>
           </a:ln>
         </p:spPr>
@@ -4835,18 +4635,18 @@
         </p:nvSpPr>
         <p:spPr>
           <a:xfrm>
-            <a:off x="3456432" y="2148840"/>
-            <a:ext cx="2542032" cy="4114800"/>
+            <a:off x="3456432" y="2084831"/>
+            <a:ext cx="2542032" cy="4160520"/>
           </a:xfrm>
           <a:prstGeom prst="rect">
             <a:avLst/>
           </a:prstGeom>
           <a:solidFill>
-            <a:srgbClr val="1A1A20"/>
+            <a:srgbClr val="0F0F14"/>
           </a:solidFill>
-          <a:ln w="12700">
+          <a:ln w="19050">
             <a:solidFill>
-              <a:srgbClr val="3C3C46"/>
+              <a:srgbClr val="E60012"/>
             </a:solidFill>
           </a:ln>
         </p:spPr>
@@ -4975,18 +4775,18 @@
         </p:nvSpPr>
         <p:spPr>
           <a:xfrm>
-            <a:off x="6181344" y="2148840"/>
-            <a:ext cx="2542032" cy="4114800"/>
+            <a:off x="6181344" y="2084831"/>
+            <a:ext cx="2542032" cy="4160520"/>
           </a:xfrm>
           <a:prstGeom prst="rect">
             <a:avLst/>
           </a:prstGeom>
           <a:solidFill>
-            <a:srgbClr val="1A1A20"/>
+            <a:srgbClr val="0F0F14"/>
           </a:solidFill>
-          <a:ln w="12700">
+          <a:ln w="19050">
             <a:solidFill>
-              <a:srgbClr val="3C3C46"/>
+              <a:srgbClr val="E60012"/>
             </a:solidFill>
           </a:ln>
         </p:spPr>
@@ -5115,18 +4915,18 @@
         </p:nvSpPr>
         <p:spPr>
           <a:xfrm>
-            <a:off x="8906256" y="2148840"/>
-            <a:ext cx="2542032" cy="4114800"/>
+            <a:off x="8906256" y="2084831"/>
+            <a:ext cx="2542032" cy="4160520"/>
           </a:xfrm>
           <a:prstGeom prst="rect">
             <a:avLst/>
           </a:prstGeom>
           <a:solidFill>
-            <a:srgbClr val="1A1A20"/>
+            <a:srgbClr val="0F0F14"/>
           </a:solidFill>
-          <a:ln w="12700">
+          <a:ln w="19050">
             <a:solidFill>
-              <a:srgbClr val="3C3C46"/>
+              <a:srgbClr val="F1E05A"/>
             </a:solidFill>
           </a:ln>
         </p:spPr>
@@ -5272,7 +5072,7 @@
             <a:pPr>
               <a:defRPr sz="1000">
                 <a:solidFill>
-                  <a:srgbClr val="AAAAB4"/>
+                  <a:srgbClr val="AFAFBE"/>
                 </a:solidFill>
                 <a:latin typeface="Arial"/>
               </a:defRPr>
@@ -5301,12 +5101,20 @@
         <p:nvPr/>
       </p:nvGrpSpPr>
       <p:grpSpPr/>
-      <p:sp>
-        <p:nvSpPr>
-          <p:cNvPr id="2" name="Rectangle 1"/>
-          <p:cNvSpPr/>
+      <p:pic>
+        <p:nvPicPr>
+          <p:cNvPr id="2" name="Picture 1" descr="bg_stripes.jpg"/>
+          <p:cNvPicPr>
+            <a:picLocks noChangeAspect="1"/>
+          </p:cNvPicPr>
           <p:nvPr/>
-        </p:nvSpPr>
+        </p:nvPicPr>
+        <p:blipFill>
+          <a:blip r:embed="rId2"/>
+          <a:stretch>
+            <a:fillRect/>
+          </a:stretch>
+        </p:blipFill>
         <p:spPr>
           <a:xfrm>
             <a:off x="0" y="0"/>
@@ -5315,35 +5123,8 @@
           <a:prstGeom prst="rect">
             <a:avLst/>
           </a:prstGeom>
-          <a:solidFill>
-            <a:srgbClr val="0E0E11"/>
-          </a:solidFill>
-          <a:ln>
-            <a:noFill/>
-          </a:ln>
-        </p:spPr>
-        <p:style>
-          <a:lnRef idx="1">
-            <a:schemeClr val="accent1"/>
-          </a:lnRef>
-          <a:fillRef idx="3">
-            <a:schemeClr val="accent1"/>
-          </a:fillRef>
-          <a:effectRef idx="2">
-            <a:schemeClr val="accent1"/>
-          </a:effectRef>
-          <a:fontRef idx="minor">
-            <a:schemeClr val="lt1"/>
-          </a:fontRef>
-        </p:style>
-        <p:txBody>
-          <a:bodyPr rtlCol="0" anchor="ctr"/>
-          <a:lstStyle/>
-          <a:p>
-            <a:pPr algn="ctr"/>
-          </a:p>
-        </p:txBody>
-      </p:sp>
+        </p:spPr>
+      </p:pic>
       <p:sp>
         <p:nvSpPr>
           <p:cNvPr id="3" name="Rectangle 2"/>
@@ -5395,8 +5176,8 @@
         </p:nvSpPr>
         <p:spPr>
           <a:xfrm>
-            <a:off x="731520" y="365760"/>
-            <a:ext cx="2560320" cy="347472"/>
+            <a:off x="731520" y="320040"/>
+            <a:ext cx="2926080" cy="329184"/>
           </a:xfrm>
           <a:prstGeom prst="rect">
             <a:avLst/>
@@ -5423,7 +5204,7 @@
           </a:fontRef>
         </p:style>
         <p:txBody>
-          <a:bodyPr rtlCol="0" anchor="ctr" wrap="square" tIns="36576"/>
+          <a:bodyPr rtlCol="0" anchor="ctr" wrap="square" lIns="109728" tIns="36576"/>
           <a:lstStyle/>
           <a:p>
             <a:pPr algn="ctr">
@@ -5440,42 +5221,30 @@
           </a:p>
         </p:txBody>
       </p:sp>
-      <p:sp>
-        <p:nvSpPr>
-          <p:cNvPr id="5" name="TextBox 4"/>
-          <p:cNvSpPr txBox="1"/>
+      <p:pic>
+        <p:nvPicPr>
+          <p:cNvPr id="5" name="Picture 4" descr="title_4.png"/>
+          <p:cNvPicPr>
+            <a:picLocks noChangeAspect="1"/>
+          </p:cNvPicPr>
           <p:nvPr/>
-        </p:nvSpPr>
-        <p:spPr>
-          <a:xfrm>
-            <a:off x="685800" y="777240"/>
-            <a:ext cx="10789920" cy="640080"/>
-          </a:xfrm>
-          <a:prstGeom prst="rect">
-            <a:avLst/>
-          </a:prstGeom>
-          <a:noFill/>
-        </p:spPr>
-        <p:txBody>
-          <a:bodyPr wrap="square">
-            <a:spAutoFit/>
-          </a:bodyPr>
-          <a:lstStyle/>
-          <a:p>
-            <a:pPr>
-              <a:defRPr sz="2400" b="1">
-                <a:solidFill>
-                  <a:srgbClr val="F6F4EF"/>
-                </a:solidFill>
-                <a:latin typeface="Arial Black"/>
-              </a:defRPr>
-            </a:pPr>
-            <a:r>
-              <a:t>SISTEM OPERASIONAL BISNIS</a:t>
-            </a:r>
-          </a:p>
-        </p:txBody>
-      </p:sp>
+        </p:nvPicPr>
+        <p:blipFill>
+          <a:blip r:embed="rId3"/>
+          <a:stretch>
+            <a:fillRect/>
+          </a:stretch>
+        </p:blipFill>
+        <p:spPr>
+          <a:xfrm>
+            <a:off x="713232" y="694944"/>
+            <a:ext cx="7324910" cy="566928"/>
+          </a:xfrm>
+          <a:prstGeom prst="rect">
+            <a:avLst/>
+          </a:prstGeom>
+        </p:spPr>
+      </p:pic>
       <p:sp>
         <p:nvSpPr>
           <p:cNvPr id="6" name="Rectangle 5"/>
@@ -5484,14 +5253,14 @@
         </p:nvSpPr>
         <p:spPr>
           <a:xfrm>
-            <a:off x="731520" y="1444752"/>
+            <a:off x="731520" y="1353312"/>
             <a:ext cx="10728655" cy="27432"/>
           </a:xfrm>
           <a:prstGeom prst="rect">
             <a:avLst/>
           </a:prstGeom>
           <a:solidFill>
-            <a:srgbClr val="A3000C"/>
+            <a:srgbClr val="E60012"/>
           </a:solidFill>
           <a:ln>
             <a:noFill/>
@@ -5527,8 +5296,8 @@
         </p:nvSpPr>
         <p:spPr>
           <a:xfrm>
-            <a:off x="685800" y="1554480"/>
-            <a:ext cx="10789920" cy="502920"/>
+            <a:off x="685800" y="1481328"/>
+            <a:ext cx="10789920" cy="457200"/>
           </a:xfrm>
           <a:prstGeom prst="rect">
             <a:avLst/>
@@ -5542,9 +5311,9 @@
           <a:lstStyle/>
           <a:p>
             <a:pPr>
-              <a:defRPr sz="1200">
-                <a:solidFill>
-                  <a:srgbClr val="AAAAB4"/>
+              <a:defRPr sz="1150">
+                <a:solidFill>
+                  <a:srgbClr val="F6F4EF"/>
                 </a:solidFill>
                 <a:latin typeface="Arial"/>
               </a:defRPr>
@@ -5563,18 +5332,18 @@
         </p:nvSpPr>
         <p:spPr>
           <a:xfrm>
-            <a:off x="731520" y="2148840"/>
+            <a:off x="731520" y="2057400"/>
             <a:ext cx="3456432" cy="1783080"/>
           </a:xfrm>
           <a:prstGeom prst="rect">
             <a:avLst/>
           </a:prstGeom>
           <a:solidFill>
-            <a:srgbClr val="1A1A20"/>
+            <a:srgbClr val="0F0F14"/>
           </a:solidFill>
           <a:ln w="19050">
             <a:solidFill>
-              <a:srgbClr val="A3000C"/>
+              <a:srgbClr val="E60012"/>
             </a:solidFill>
           </a:ln>
         </p:spPr>
@@ -5623,9 +5392,9 @@
           </a:p>
           <a:p>
             <a:pPr>
-              <a:defRPr sz="1050">
-                <a:solidFill>
-                  <a:srgbClr val="AAAAB4"/>
+              <a:defRPr sz="1000">
+                <a:solidFill>
+                  <a:srgbClr val="AFAFBE"/>
                 </a:solidFill>
                 <a:latin typeface="Arial"/>
               </a:defRPr>
@@ -5644,18 +5413,18 @@
         </p:nvSpPr>
         <p:spPr>
           <a:xfrm>
-            <a:off x="4370832" y="2148840"/>
+            <a:off x="4370832" y="2057400"/>
             <a:ext cx="3456432" cy="1783080"/>
           </a:xfrm>
           <a:prstGeom prst="rect">
             <a:avLst/>
           </a:prstGeom>
           <a:solidFill>
-            <a:srgbClr val="1A1A20"/>
+            <a:srgbClr val="0F0F14"/>
           </a:solidFill>
           <a:ln w="19050">
             <a:solidFill>
-              <a:srgbClr val="A3000C"/>
+              <a:srgbClr val="E60012"/>
             </a:solidFill>
           </a:ln>
         </p:spPr>
@@ -5704,9 +5473,9 @@
           </a:p>
           <a:p>
             <a:pPr>
-              <a:defRPr sz="1050">
-                <a:solidFill>
-                  <a:srgbClr val="AAAAB4"/>
+              <a:defRPr sz="1000">
+                <a:solidFill>
+                  <a:srgbClr val="AFAFBE"/>
                 </a:solidFill>
                 <a:latin typeface="Arial"/>
               </a:defRPr>
@@ -5725,18 +5494,18 @@
         </p:nvSpPr>
         <p:spPr>
           <a:xfrm>
-            <a:off x="8010144" y="2148840"/>
+            <a:off x="8010144" y="2057400"/>
             <a:ext cx="3456432" cy="1783080"/>
           </a:xfrm>
           <a:prstGeom prst="rect">
             <a:avLst/>
           </a:prstGeom>
           <a:solidFill>
-            <a:srgbClr val="1A1A20"/>
+            <a:srgbClr val="0F0F14"/>
           </a:solidFill>
           <a:ln w="19050">
             <a:solidFill>
-              <a:srgbClr val="A3000C"/>
+              <a:srgbClr val="E60012"/>
             </a:solidFill>
           </a:ln>
         </p:spPr>
@@ -5785,9 +5554,9 @@
           </a:p>
           <a:p>
             <a:pPr>
-              <a:defRPr sz="1050">
-                <a:solidFill>
-                  <a:srgbClr val="AAAAB4"/>
+              <a:defRPr sz="1000">
+                <a:solidFill>
+                  <a:srgbClr val="AFAFBE"/>
                 </a:solidFill>
                 <a:latin typeface="Arial"/>
               </a:defRPr>
@@ -5806,18 +5575,18 @@
         </p:nvSpPr>
         <p:spPr>
           <a:xfrm>
-            <a:off x="731520" y="4114800"/>
+            <a:off x="731520" y="4023360"/>
             <a:ext cx="3456432" cy="1783080"/>
           </a:xfrm>
           <a:prstGeom prst="rect">
             <a:avLst/>
           </a:prstGeom>
           <a:solidFill>
-            <a:srgbClr val="1A1A20"/>
+            <a:srgbClr val="0F0F14"/>
           </a:solidFill>
           <a:ln w="19050">
             <a:solidFill>
-              <a:srgbClr val="A3000C"/>
+              <a:srgbClr val="E60012"/>
             </a:solidFill>
           </a:ln>
         </p:spPr>
@@ -5866,9 +5635,9 @@
           </a:p>
           <a:p>
             <a:pPr>
-              <a:defRPr sz="1050">
-                <a:solidFill>
-                  <a:srgbClr val="AAAAB4"/>
+              <a:defRPr sz="1000">
+                <a:solidFill>
+                  <a:srgbClr val="AFAFBE"/>
                 </a:solidFill>
                 <a:latin typeface="Arial"/>
               </a:defRPr>
@@ -5887,18 +5656,18 @@
         </p:nvSpPr>
         <p:spPr>
           <a:xfrm>
-            <a:off x="4370832" y="4114800"/>
+            <a:off x="4370832" y="4023360"/>
             <a:ext cx="3456432" cy="1783080"/>
           </a:xfrm>
           <a:prstGeom prst="rect">
             <a:avLst/>
           </a:prstGeom>
           <a:solidFill>
-            <a:srgbClr val="1A1A20"/>
+            <a:srgbClr val="0F0F14"/>
           </a:solidFill>
           <a:ln w="19050">
             <a:solidFill>
-              <a:srgbClr val="A3000C"/>
+              <a:srgbClr val="E60012"/>
             </a:solidFill>
           </a:ln>
         </p:spPr>
@@ -5947,9 +5716,9 @@
           </a:p>
           <a:p>
             <a:pPr>
-              <a:defRPr sz="1050">
-                <a:solidFill>
-                  <a:srgbClr val="AAAAB4"/>
+              <a:defRPr sz="1000">
+                <a:solidFill>
+                  <a:srgbClr val="AFAFBE"/>
                 </a:solidFill>
                 <a:latin typeface="Arial"/>
               </a:defRPr>
@@ -5968,18 +5737,18 @@
         </p:nvSpPr>
         <p:spPr>
           <a:xfrm>
-            <a:off x="8010144" y="4114800"/>
+            <a:off x="8010144" y="4023360"/>
             <a:ext cx="3456432" cy="1783080"/>
           </a:xfrm>
           <a:prstGeom prst="rect">
             <a:avLst/>
           </a:prstGeom>
           <a:solidFill>
-            <a:srgbClr val="1A1A20"/>
+            <a:srgbClr val="0F0F14"/>
           </a:solidFill>
           <a:ln w="19050">
             <a:solidFill>
-              <a:srgbClr val="A3000C"/>
+              <a:srgbClr val="E60012"/>
             </a:solidFill>
           </a:ln>
         </p:spPr>
@@ -6028,9 +5797,9 @@
           </a:p>
           <a:p>
             <a:pPr>
-              <a:defRPr sz="1050">
-                <a:solidFill>
-                  <a:srgbClr val="AAAAB4"/>
+              <a:defRPr sz="1000">
+                <a:solidFill>
+                  <a:srgbClr val="AFAFBE"/>
                 </a:solidFill>
                 <a:latin typeface="Arial"/>
               </a:defRPr>
@@ -6056,11 +5825,11 @@
             <a:avLst/>
           </a:prstGeom>
           <a:solidFill>
-            <a:srgbClr val="1A1A20"/>
+            <a:srgbClr val="0F0F14"/>
           </a:solidFill>
           <a:ln>
             <a:solidFill>
-              <a:srgbClr val="3C3C46"/>
+              <a:srgbClr val="3C3C48"/>
             </a:solidFill>
           </a:ln>
         </p:spPr>
@@ -6091,7 +5860,7 @@
               </a:defRPr>
             </a:pPr>
             <a:r>
-              <a:t>STATUS OPERASIONAL: Saat ini pesanan ditangani via admin. Integrasi Bot @Sanzstrnokosmumerbot terus disempurnakan untuk otomasi alur transaksi.</a:t>
+              <a:t>★ STATUS OPERASIONAL: Saat ini pesanan ditangani via admin. Integrasi Bot @Sanzstrnokosmumerbot terus disempurnakan untuk otomasi alur transaksi.</a:t>
             </a:r>
           </a:p>
         </p:txBody>
@@ -6121,7 +5890,7 @@
             <a:pPr>
               <a:defRPr sz="1000">
                 <a:solidFill>
-                  <a:srgbClr val="AAAAB4"/>
+                  <a:srgbClr val="AFAFBE"/>
                 </a:solidFill>
                 <a:latin typeface="Arial"/>
               </a:defRPr>
@@ -6150,12 +5919,20 @@
         <p:nvPr/>
       </p:nvGrpSpPr>
       <p:grpSpPr/>
-      <p:sp>
-        <p:nvSpPr>
-          <p:cNvPr id="2" name="Rectangle 1"/>
-          <p:cNvSpPr/>
+      <p:pic>
+        <p:nvPicPr>
+          <p:cNvPr id="2" name="Picture 1" descr="bg_slide5.jpg"/>
+          <p:cNvPicPr>
+            <a:picLocks noChangeAspect="1"/>
+          </p:cNvPicPr>
           <p:nvPr/>
-        </p:nvSpPr>
+        </p:nvPicPr>
+        <p:blipFill>
+          <a:blip r:embed="rId2"/>
+          <a:stretch>
+            <a:fillRect/>
+          </a:stretch>
+        </p:blipFill>
         <p:spPr>
           <a:xfrm>
             <a:off x="0" y="0"/>
@@ -6164,35 +5941,8 @@
           <a:prstGeom prst="rect">
             <a:avLst/>
           </a:prstGeom>
-          <a:solidFill>
-            <a:srgbClr val="0E0E11"/>
-          </a:solidFill>
-          <a:ln>
-            <a:noFill/>
-          </a:ln>
-        </p:spPr>
-        <p:style>
-          <a:lnRef idx="1">
-            <a:schemeClr val="accent1"/>
-          </a:lnRef>
-          <a:fillRef idx="3">
-            <a:schemeClr val="accent1"/>
-          </a:fillRef>
-          <a:effectRef idx="2">
-            <a:schemeClr val="accent1"/>
-          </a:effectRef>
-          <a:fontRef idx="minor">
-            <a:schemeClr val="lt1"/>
-          </a:fontRef>
-        </p:style>
-        <p:txBody>
-          <a:bodyPr rtlCol="0" anchor="ctr"/>
-          <a:lstStyle/>
-          <a:p>
-            <a:pPr algn="ctr"/>
-          </a:p>
-        </p:txBody>
-      </p:sp>
+        </p:spPr>
+      </p:pic>
       <p:sp>
         <p:nvSpPr>
           <p:cNvPr id="3" name="Rectangle 2"/>
@@ -6244,8 +5994,8 @@
         </p:nvSpPr>
         <p:spPr>
           <a:xfrm>
-            <a:off x="731520" y="365760"/>
-            <a:ext cx="2560320" cy="347472"/>
+            <a:off x="731520" y="320040"/>
+            <a:ext cx="2926080" cy="329184"/>
           </a:xfrm>
           <a:prstGeom prst="rect">
             <a:avLst/>
@@ -6272,7 +6022,7 @@
           </a:fontRef>
         </p:style>
         <p:txBody>
-          <a:bodyPr rtlCol="0" anchor="ctr" wrap="square" tIns="36576"/>
+          <a:bodyPr rtlCol="0" anchor="ctr" wrap="square" lIns="109728" tIns="36576"/>
           <a:lstStyle/>
           <a:p>
             <a:pPr algn="ctr">
@@ -6289,42 +6039,30 @@
           </a:p>
         </p:txBody>
       </p:sp>
-      <p:sp>
-        <p:nvSpPr>
-          <p:cNvPr id="5" name="TextBox 4"/>
-          <p:cNvSpPr txBox="1"/>
+      <p:pic>
+        <p:nvPicPr>
+          <p:cNvPr id="5" name="Picture 4" descr="title_5.png"/>
+          <p:cNvPicPr>
+            <a:picLocks noChangeAspect="1"/>
+          </p:cNvPicPr>
           <p:nvPr/>
-        </p:nvSpPr>
-        <p:spPr>
-          <a:xfrm>
-            <a:off x="685800" y="777240"/>
-            <a:ext cx="10789920" cy="640080"/>
-          </a:xfrm>
-          <a:prstGeom prst="rect">
-            <a:avLst/>
-          </a:prstGeom>
-          <a:noFill/>
-        </p:spPr>
-        <p:txBody>
-          <a:bodyPr wrap="square">
-            <a:spAutoFit/>
-          </a:bodyPr>
-          <a:lstStyle/>
-          <a:p>
-            <a:pPr>
-              <a:defRPr sz="2400" b="1">
-                <a:solidFill>
-                  <a:srgbClr val="F6F4EF"/>
-                </a:solidFill>
-                <a:latin typeface="Arial Black"/>
-              </a:defRPr>
-            </a:pPr>
-            <a:r>
-              <a:t>STRATEGI PEMASARAN &amp; PELAYANAN PELANGGAN</a:t>
-            </a:r>
-          </a:p>
-        </p:txBody>
-      </p:sp>
+        </p:nvPicPr>
+        <p:blipFill>
+          <a:blip r:embed="rId3"/>
+          <a:stretch>
+            <a:fillRect/>
+          </a:stretch>
+        </p:blipFill>
+        <p:spPr>
+          <a:xfrm>
+            <a:off x="713232" y="694944"/>
+            <a:ext cx="5483648" cy="566928"/>
+          </a:xfrm>
+          <a:prstGeom prst="rect">
+            <a:avLst/>
+          </a:prstGeom>
+        </p:spPr>
+      </p:pic>
       <p:sp>
         <p:nvSpPr>
           <p:cNvPr id="6" name="Rectangle 5"/>
@@ -6333,14 +6071,14 @@
         </p:nvSpPr>
         <p:spPr>
           <a:xfrm>
-            <a:off x="731520" y="1444752"/>
+            <a:off x="731520" y="1353312"/>
             <a:ext cx="10728655" cy="27432"/>
           </a:xfrm>
           <a:prstGeom prst="rect">
             <a:avLst/>
           </a:prstGeom>
           <a:solidFill>
-            <a:srgbClr val="A3000C"/>
+            <a:srgbClr val="E60012"/>
           </a:solidFill>
           <a:ln>
             <a:noFill/>
@@ -6376,14 +6114,14 @@
         </p:nvSpPr>
         <p:spPr>
           <a:xfrm>
-            <a:off x="731520" y="1691640"/>
-            <a:ext cx="5242255" cy="3566160"/>
+            <a:off x="731520" y="1600200"/>
+            <a:ext cx="5242255" cy="3657600"/>
           </a:xfrm>
           <a:prstGeom prst="rect">
             <a:avLst/>
           </a:prstGeom>
           <a:solidFill>
-            <a:srgbClr val="1A1A20"/>
+            <a:srgbClr val="0F0F14"/>
           </a:solidFill>
           <a:ln w="19050">
             <a:solidFill>
@@ -6406,11 +6144,11 @@
           </a:fontRef>
         </p:style>
         <p:txBody>
-          <a:bodyPr rtlCol="0" anchor="ctr" wrap="square" lIns="228600" rIns="228600" tIns="182880"/>
+          <a:bodyPr rtlCol="0" anchor="ctr" wrap="square" lIns="228600" rIns="228600" tIns="164592"/>
           <a:lstStyle/>
           <a:p>
             <a:pPr algn="ctr">
-              <a:defRPr sz="1400" b="1">
+              <a:defRPr sz="1300" b="1">
                 <a:solidFill>
                   <a:srgbClr val="E60012"/>
                 </a:solidFill>
@@ -6439,9 +6177,9 @@
           </a:p>
           <a:p>
             <a:pPr>
-              <a:defRPr sz="1000">
-                <a:solidFill>
-                  <a:srgbClr val="AAAAB4"/>
+              <a:defRPr sz="950">
+                <a:solidFill>
+                  <a:srgbClr val="AFAFBE"/>
                 </a:solidFill>
                 <a:latin typeface="Arial"/>
               </a:defRPr>
@@ -6468,9 +6206,9 @@
           </a:p>
           <a:p>
             <a:pPr>
-              <a:defRPr sz="1000">
-                <a:solidFill>
-                  <a:srgbClr val="AAAAB4"/>
+              <a:defRPr sz="950">
+                <a:solidFill>
+                  <a:srgbClr val="AFAFBE"/>
                 </a:solidFill>
                 <a:latin typeface="Arial"/>
               </a:defRPr>
@@ -6497,9 +6235,9 @@
           </a:p>
           <a:p>
             <a:pPr>
-              <a:defRPr sz="1000">
-                <a:solidFill>
-                  <a:srgbClr val="AAAAB4"/>
+              <a:defRPr sz="950">
+                <a:solidFill>
+                  <a:srgbClr val="AFAFBE"/>
                 </a:solidFill>
                 <a:latin typeface="Arial"/>
               </a:defRPr>
@@ -6526,9 +6264,9 @@
           </a:p>
           <a:p>
             <a:pPr>
-              <a:defRPr sz="1000">
-                <a:solidFill>
-                  <a:srgbClr val="AAAAB4"/>
+              <a:defRPr sz="950">
+                <a:solidFill>
+                  <a:srgbClr val="AFAFBE"/>
                 </a:solidFill>
                 <a:latin typeface="Arial"/>
               </a:defRPr>
@@ -6547,14 +6285,14 @@
         </p:nvSpPr>
         <p:spPr>
           <a:xfrm>
-            <a:off x="6217920" y="1691640"/>
-            <a:ext cx="5242255" cy="3566160"/>
+            <a:off x="6217920" y="1600200"/>
+            <a:ext cx="5242255" cy="3657600"/>
           </a:xfrm>
           <a:prstGeom prst="rect">
             <a:avLst/>
           </a:prstGeom>
           <a:solidFill>
-            <a:srgbClr val="1A1A20"/>
+            <a:srgbClr val="0F0F14"/>
           </a:solidFill>
           <a:ln w="19050">
             <a:solidFill>
@@ -6577,11 +6315,11 @@
           </a:fontRef>
         </p:style>
         <p:txBody>
-          <a:bodyPr rtlCol="0" anchor="ctr" wrap="square" lIns="228600" rIns="228600" tIns="182880"/>
+          <a:bodyPr rtlCol="0" anchor="ctr" wrap="square" lIns="228600" rIns="228600" tIns="164592"/>
           <a:lstStyle/>
           <a:p>
             <a:pPr algn="ctr">
-              <a:defRPr sz="1400" b="1">
+              <a:defRPr sz="1300" b="1">
                 <a:solidFill>
                   <a:srgbClr val="E60012"/>
                 </a:solidFill>
@@ -6610,9 +6348,9 @@
           </a:p>
           <a:p>
             <a:pPr>
-              <a:defRPr sz="1000">
-                <a:solidFill>
-                  <a:srgbClr val="AAAAB4"/>
+              <a:defRPr sz="950">
+                <a:solidFill>
+                  <a:srgbClr val="AFAFBE"/>
                 </a:solidFill>
                 <a:latin typeface="Arial"/>
               </a:defRPr>
@@ -6639,9 +6377,9 @@
           </a:p>
           <a:p>
             <a:pPr>
-              <a:defRPr sz="1000">
-                <a:solidFill>
-                  <a:srgbClr val="AAAAB4"/>
+              <a:defRPr sz="950">
+                <a:solidFill>
+                  <a:srgbClr val="AFAFBE"/>
                 </a:solidFill>
                 <a:latin typeface="Arial"/>
               </a:defRPr>
@@ -6668,9 +6406,9 @@
           </a:p>
           <a:p>
             <a:pPr>
-              <a:defRPr sz="1000">
-                <a:solidFill>
-                  <a:srgbClr val="AAAAB4"/>
+              <a:defRPr sz="950">
+                <a:solidFill>
+                  <a:srgbClr val="AFAFBE"/>
                 </a:solidFill>
                 <a:latin typeface="Arial"/>
               </a:defRPr>
@@ -6697,9 +6435,9 @@
           </a:p>
           <a:p>
             <a:pPr>
-              <a:defRPr sz="1000">
-                <a:solidFill>
-                  <a:srgbClr val="AAAAB4"/>
+              <a:defRPr sz="950">
+                <a:solidFill>
+                  <a:srgbClr val="AFAFBE"/>
                 </a:solidFill>
                 <a:latin typeface="Arial"/>
               </a:defRPr>
@@ -6725,7 +6463,7 @@
             <a:avLst/>
           </a:prstGeom>
           <a:solidFill>
-            <a:srgbClr val="1A1A20"/>
+            <a:srgbClr val="0F0F14"/>
           </a:solidFill>
           <a:ln w="19050">
             <a:solidFill>
@@ -6760,7 +6498,7 @@
               </a:defRPr>
             </a:pPr>
             <a:r>
-              <a:t>KANAL RESMI KOMUNIKASI &amp; TRANSAKSI:</a:t>
+              <a:t>★ KANAL RESMI KOMUNIKASI &amp; TRANSAKSI:</a:t>
             </a:r>
           </a:p>
           <a:p>
@@ -6803,7 +6541,7 @@
             <a:pPr>
               <a:defRPr sz="1000">
                 <a:solidFill>
-                  <a:srgbClr val="AAAAB4"/>
+                  <a:srgbClr val="AFAFBE"/>
                 </a:solidFill>
                 <a:latin typeface="Arial"/>
               </a:defRPr>
@@ -6832,12 +6570,20 @@
         <p:nvPr/>
       </p:nvGrpSpPr>
       <p:grpSpPr/>
-      <p:sp>
-        <p:nvSpPr>
-          <p:cNvPr id="2" name="Rectangle 1"/>
-          <p:cNvSpPr/>
+      <p:pic>
+        <p:nvPicPr>
+          <p:cNvPr id="2" name="Picture 1" descr="bg_slide6.jpg"/>
+          <p:cNvPicPr>
+            <a:picLocks noChangeAspect="1"/>
+          </p:cNvPicPr>
           <p:nvPr/>
-        </p:nvSpPr>
+        </p:nvPicPr>
+        <p:blipFill>
+          <a:blip r:embed="rId2"/>
+          <a:stretch>
+            <a:fillRect/>
+          </a:stretch>
+        </p:blipFill>
         <p:spPr>
           <a:xfrm>
             <a:off x="0" y="0"/>
@@ -6846,35 +6592,8 @@
           <a:prstGeom prst="rect">
             <a:avLst/>
           </a:prstGeom>
-          <a:solidFill>
-            <a:srgbClr val="0E0E11"/>
-          </a:solidFill>
-          <a:ln>
-            <a:noFill/>
-          </a:ln>
-        </p:spPr>
-        <p:style>
-          <a:lnRef idx="1">
-            <a:schemeClr val="accent1"/>
-          </a:lnRef>
-          <a:fillRef idx="3">
-            <a:schemeClr val="accent1"/>
-          </a:fillRef>
-          <a:effectRef idx="2">
-            <a:schemeClr val="accent1"/>
-          </a:effectRef>
-          <a:fontRef idx="minor">
-            <a:schemeClr val="lt1"/>
-          </a:fontRef>
-        </p:style>
-        <p:txBody>
-          <a:bodyPr rtlCol="0" anchor="ctr"/>
-          <a:lstStyle/>
-          <a:p>
-            <a:pPr algn="ctr"/>
-          </a:p>
-        </p:txBody>
-      </p:sp>
+        </p:spPr>
+      </p:pic>
       <p:sp>
         <p:nvSpPr>
           <p:cNvPr id="3" name="Rectangle 2"/>
@@ -6926,8 +6645,8 @@
         </p:nvSpPr>
         <p:spPr>
           <a:xfrm>
-            <a:off x="731520" y="365760"/>
-            <a:ext cx="2560320" cy="347472"/>
+            <a:off x="731520" y="320040"/>
+            <a:ext cx="2926080" cy="329184"/>
           </a:xfrm>
           <a:prstGeom prst="rect">
             <a:avLst/>
@@ -6954,7 +6673,7 @@
           </a:fontRef>
         </p:style>
         <p:txBody>
-          <a:bodyPr rtlCol="0" anchor="ctr" wrap="square" tIns="36576"/>
+          <a:bodyPr rtlCol="0" anchor="ctr" wrap="square" lIns="109728" tIns="36576"/>
           <a:lstStyle/>
           <a:p>
             <a:pPr algn="ctr">
@@ -6971,42 +6690,30 @@
           </a:p>
         </p:txBody>
       </p:sp>
-      <p:sp>
-        <p:nvSpPr>
-          <p:cNvPr id="5" name="TextBox 4"/>
-          <p:cNvSpPr txBox="1"/>
+      <p:pic>
+        <p:nvPicPr>
+          <p:cNvPr id="5" name="Picture 4" descr="title_6.png"/>
+          <p:cNvPicPr>
+            <a:picLocks noChangeAspect="1"/>
+          </p:cNvPicPr>
           <p:nvPr/>
-        </p:nvSpPr>
-        <p:spPr>
-          <a:xfrm>
-            <a:off x="685800" y="777240"/>
-            <a:ext cx="10789920" cy="640080"/>
-          </a:xfrm>
-          <a:prstGeom prst="rect">
-            <a:avLst/>
-          </a:prstGeom>
-          <a:noFill/>
-        </p:spPr>
-        <p:txBody>
-          <a:bodyPr wrap="square">
-            <a:spAutoFit/>
-          </a:bodyPr>
-          <a:lstStyle/>
-          <a:p>
-            <a:pPr>
-              <a:defRPr sz="2400" b="1">
-                <a:solidFill>
-                  <a:srgbClr val="F6F4EF"/>
-                </a:solidFill>
-                <a:latin typeface="Arial Black"/>
-              </a:defRPr>
-            </a:pPr>
-            <a:r>
-              <a:t>TEKNOLOGI PENDUKUNG BISNIS</a:t>
-            </a:r>
-          </a:p>
-        </p:txBody>
-      </p:sp>
+        </p:nvPicPr>
+        <p:blipFill>
+          <a:blip r:embed="rId3"/>
+          <a:stretch>
+            <a:fillRect/>
+          </a:stretch>
+        </p:blipFill>
+        <p:spPr>
+          <a:xfrm>
+            <a:off x="713232" y="694944"/>
+            <a:ext cx="7936992" cy="566928"/>
+          </a:xfrm>
+          <a:prstGeom prst="rect">
+            <a:avLst/>
+          </a:prstGeom>
+        </p:spPr>
+      </p:pic>
       <p:sp>
         <p:nvSpPr>
           <p:cNvPr id="6" name="Rectangle 5"/>
@@ -7015,14 +6722,14 @@
         </p:nvSpPr>
         <p:spPr>
           <a:xfrm>
-            <a:off x="731520" y="1444752"/>
+            <a:off x="731520" y="1353312"/>
             <a:ext cx="10728655" cy="27432"/>
           </a:xfrm>
           <a:prstGeom prst="rect">
             <a:avLst/>
           </a:prstGeom>
           <a:solidFill>
-            <a:srgbClr val="A3000C"/>
+            <a:srgbClr val="E60012"/>
           </a:solidFill>
           <a:ln>
             <a:noFill/>
@@ -7058,14 +6765,14 @@
         </p:nvSpPr>
         <p:spPr>
           <a:xfrm>
-            <a:off x="731520" y="1691640"/>
-            <a:ext cx="5242255" cy="4526280"/>
+            <a:off x="731520" y="1600200"/>
+            <a:ext cx="5242255" cy="4617720"/>
           </a:xfrm>
           <a:prstGeom prst="rect">
             <a:avLst/>
           </a:prstGeom>
           <a:solidFill>
-            <a:srgbClr val="1A1A20"/>
+            <a:srgbClr val="0F0F14"/>
           </a:solidFill>
           <a:ln w="19050">
             <a:solidFill>
@@ -7106,7 +6813,7 @@
           <a:p>
             <a:pPr>
               <a:spcBef>
-                <a:spcPts val="600"/>
+                <a:spcPts val="500"/>
               </a:spcBef>
               <a:defRPr sz="1100">
                 <a:solidFill>
@@ -7123,7 +6830,7 @@
             <a:pPr>
               <a:defRPr sz="950">
                 <a:solidFill>
-                  <a:srgbClr val="AAAAB4"/>
+                  <a:srgbClr val="AFAFBE"/>
                 </a:solidFill>
                 <a:latin typeface="Arial"/>
               </a:defRPr>
@@ -7135,7 +6842,7 @@
           <a:p>
             <a:pPr>
               <a:spcBef>
-                <a:spcPts val="600"/>
+                <a:spcPts val="500"/>
               </a:spcBef>
               <a:defRPr sz="1100">
                 <a:solidFill>
@@ -7152,7 +6859,7 @@
             <a:pPr>
               <a:defRPr sz="950">
                 <a:solidFill>
-                  <a:srgbClr val="AAAAB4"/>
+                  <a:srgbClr val="AFAFBE"/>
                 </a:solidFill>
                 <a:latin typeface="Arial"/>
               </a:defRPr>
@@ -7164,7 +6871,7 @@
           <a:p>
             <a:pPr>
               <a:spcBef>
-                <a:spcPts val="600"/>
+                <a:spcPts val="500"/>
               </a:spcBef>
               <a:defRPr sz="1100">
                 <a:solidFill>
@@ -7181,7 +6888,7 @@
             <a:pPr>
               <a:defRPr sz="950">
                 <a:solidFill>
-                  <a:srgbClr val="AAAAB4"/>
+                  <a:srgbClr val="AFAFBE"/>
                 </a:solidFill>
                 <a:latin typeface="Arial"/>
               </a:defRPr>
@@ -7193,7 +6900,7 @@
           <a:p>
             <a:pPr>
               <a:spcBef>
-                <a:spcPts val="600"/>
+                <a:spcPts val="500"/>
               </a:spcBef>
               <a:defRPr sz="1100">
                 <a:solidFill>
@@ -7210,7 +6917,7 @@
             <a:pPr>
               <a:defRPr sz="950">
                 <a:solidFill>
-                  <a:srgbClr val="AAAAB4"/>
+                  <a:srgbClr val="AFAFBE"/>
                 </a:solidFill>
                 <a:latin typeface="Arial"/>
               </a:defRPr>
@@ -7222,7 +6929,7 @@
           <a:p>
             <a:pPr>
               <a:spcBef>
-                <a:spcPts val="600"/>
+                <a:spcPts val="500"/>
               </a:spcBef>
               <a:defRPr sz="1100">
                 <a:solidFill>
@@ -7239,7 +6946,7 @@
             <a:pPr>
               <a:defRPr sz="950">
                 <a:solidFill>
-                  <a:srgbClr val="AAAAB4"/>
+                  <a:srgbClr val="AFAFBE"/>
                 </a:solidFill>
                 <a:latin typeface="Arial"/>
               </a:defRPr>
@@ -7258,14 +6965,14 @@
         </p:nvSpPr>
         <p:spPr>
           <a:xfrm>
-            <a:off x="6217920" y="1691640"/>
-            <a:ext cx="5242255" cy="4526280"/>
+            <a:off x="6217920" y="1600200"/>
+            <a:ext cx="5242255" cy="4617720"/>
           </a:xfrm>
           <a:prstGeom prst="rect">
             <a:avLst/>
           </a:prstGeom>
           <a:solidFill>
-            <a:srgbClr val="1A1A20"/>
+            <a:srgbClr val="0F0F14"/>
           </a:solidFill>
           <a:ln w="19050">
             <a:solidFill>
@@ -7306,7 +7013,7 @@
           <a:p>
             <a:pPr>
               <a:spcBef>
-                <a:spcPts val="600"/>
+                <a:spcPts val="500"/>
               </a:spcBef>
               <a:defRPr sz="1100">
                 <a:solidFill>
@@ -7323,7 +7030,7 @@
             <a:pPr>
               <a:defRPr sz="950">
                 <a:solidFill>
-                  <a:srgbClr val="AAAAB4"/>
+                  <a:srgbClr val="AFAFBE"/>
                 </a:solidFill>
                 <a:latin typeface="Arial"/>
               </a:defRPr>
@@ -7335,7 +7042,7 @@
           <a:p>
             <a:pPr>
               <a:spcBef>
-                <a:spcPts val="600"/>
+                <a:spcPts val="500"/>
               </a:spcBef>
               <a:defRPr sz="1100">
                 <a:solidFill>
@@ -7352,7 +7059,7 @@
             <a:pPr>
               <a:defRPr sz="950">
                 <a:solidFill>
-                  <a:srgbClr val="AAAAB4"/>
+                  <a:srgbClr val="AFAFBE"/>
                 </a:solidFill>
                 <a:latin typeface="Arial"/>
               </a:defRPr>
@@ -7364,7 +7071,7 @@
           <a:p>
             <a:pPr>
               <a:spcBef>
-                <a:spcPts val="600"/>
+                <a:spcPts val="500"/>
               </a:spcBef>
               <a:defRPr sz="1100">
                 <a:solidFill>
@@ -7381,7 +7088,7 @@
             <a:pPr>
               <a:defRPr sz="950">
                 <a:solidFill>
-                  <a:srgbClr val="AAAAB4"/>
+                  <a:srgbClr val="AFAFBE"/>
                 </a:solidFill>
                 <a:latin typeface="Arial"/>
               </a:defRPr>
@@ -7393,7 +7100,7 @@
           <a:p>
             <a:pPr>
               <a:spcBef>
-                <a:spcPts val="600"/>
+                <a:spcPts val="500"/>
               </a:spcBef>
               <a:defRPr sz="1100">
                 <a:solidFill>
@@ -7410,7 +7117,7 @@
             <a:pPr>
               <a:defRPr sz="950">
                 <a:solidFill>
-                  <a:srgbClr val="AAAAB4"/>
+                  <a:srgbClr val="AFAFBE"/>
                 </a:solidFill>
                 <a:latin typeface="Arial"/>
               </a:defRPr>
@@ -7454,7 +7161,7 @@
             <a:pPr>
               <a:defRPr sz="1000">
                 <a:solidFill>
-                  <a:srgbClr val="AAAAB4"/>
+                  <a:srgbClr val="AFAFBE"/>
                 </a:solidFill>
                 <a:latin typeface="Arial"/>
               </a:defRPr>
@@ -7483,12 +7190,20 @@
         <p:nvPr/>
       </p:nvGrpSpPr>
       <p:grpSpPr/>
-      <p:sp>
-        <p:nvSpPr>
-          <p:cNvPr id="2" name="Rectangle 1"/>
-          <p:cNvSpPr/>
+      <p:pic>
+        <p:nvPicPr>
+          <p:cNvPr id="2" name="Picture 1" descr="bg_stripes.jpg"/>
+          <p:cNvPicPr>
+            <a:picLocks noChangeAspect="1"/>
+          </p:cNvPicPr>
           <p:nvPr/>
-        </p:nvSpPr>
+        </p:nvPicPr>
+        <p:blipFill>
+          <a:blip r:embed="rId2"/>
+          <a:stretch>
+            <a:fillRect/>
+          </a:stretch>
+        </p:blipFill>
         <p:spPr>
           <a:xfrm>
             <a:off x="0" y="0"/>
@@ -7497,35 +7212,8 @@
           <a:prstGeom prst="rect">
             <a:avLst/>
           </a:prstGeom>
-          <a:solidFill>
-            <a:srgbClr val="0E0E11"/>
-          </a:solidFill>
-          <a:ln>
-            <a:noFill/>
-          </a:ln>
-        </p:spPr>
-        <p:style>
-          <a:lnRef idx="1">
-            <a:schemeClr val="accent1"/>
-          </a:lnRef>
-          <a:fillRef idx="3">
-            <a:schemeClr val="accent1"/>
-          </a:fillRef>
-          <a:effectRef idx="2">
-            <a:schemeClr val="accent1"/>
-          </a:effectRef>
-          <a:fontRef idx="minor">
-            <a:schemeClr val="lt1"/>
-          </a:fontRef>
-        </p:style>
-        <p:txBody>
-          <a:bodyPr rtlCol="0" anchor="ctr"/>
-          <a:lstStyle/>
-          <a:p>
-            <a:pPr algn="ctr"/>
-          </a:p>
-        </p:txBody>
-      </p:sp>
+        </p:spPr>
+      </p:pic>
       <p:sp>
         <p:nvSpPr>
           <p:cNvPr id="3" name="Rectangle 2"/>
@@ -7577,8 +7265,8 @@
         </p:nvSpPr>
         <p:spPr>
           <a:xfrm>
-            <a:off x="731520" y="365760"/>
-            <a:ext cx="2560320" cy="347472"/>
+            <a:off x="731520" y="320040"/>
+            <a:ext cx="2926080" cy="329184"/>
           </a:xfrm>
           <a:prstGeom prst="rect">
             <a:avLst/>
@@ -7605,7 +7293,7 @@
           </a:fontRef>
         </p:style>
         <p:txBody>
-          <a:bodyPr rtlCol="0" anchor="ctr" wrap="square" tIns="36576"/>
+          <a:bodyPr rtlCol="0" anchor="ctr" wrap="square" lIns="109728" tIns="36576"/>
           <a:lstStyle/>
           <a:p>
             <a:pPr algn="ctr">
@@ -7622,42 +7310,30 @@
           </a:p>
         </p:txBody>
       </p:sp>
-      <p:sp>
-        <p:nvSpPr>
-          <p:cNvPr id="5" name="TextBox 4"/>
-          <p:cNvSpPr txBox="1"/>
+      <p:pic>
+        <p:nvPicPr>
+          <p:cNvPr id="5" name="Picture 4" descr="title_7.png"/>
+          <p:cNvPicPr>
+            <a:picLocks noChangeAspect="1"/>
+          </p:cNvPicPr>
           <p:nvPr/>
-        </p:nvSpPr>
-        <p:spPr>
-          <a:xfrm>
-            <a:off x="685800" y="777240"/>
-            <a:ext cx="10789920" cy="640080"/>
-          </a:xfrm>
-          <a:prstGeom prst="rect">
-            <a:avLst/>
-          </a:prstGeom>
-          <a:noFill/>
-        </p:spPr>
-        <p:txBody>
-          <a:bodyPr wrap="square">
-            <a:spAutoFit/>
-          </a:bodyPr>
-          <a:lstStyle/>
-          <a:p>
-            <a:pPr>
-              <a:defRPr sz="2400" b="1">
-                <a:solidFill>
-                  <a:srgbClr val="F6F4EF"/>
-                </a:solidFill>
-                <a:latin typeface="Arial Black"/>
-              </a:defRPr>
-            </a:pPr>
-            <a:r>
-              <a:t>VISI DAN RENCANA PENGEMBANGAN</a:t>
-            </a:r>
-          </a:p>
-        </p:txBody>
-      </p:sp>
+        </p:nvPicPr>
+        <p:blipFill>
+          <a:blip r:embed="rId3"/>
+          <a:stretch>
+            <a:fillRect/>
+          </a:stretch>
+        </p:blipFill>
+        <p:spPr>
+          <a:xfrm>
+            <a:off x="713232" y="694944"/>
+            <a:ext cx="8468800" cy="566928"/>
+          </a:xfrm>
+          <a:prstGeom prst="rect">
+            <a:avLst/>
+          </a:prstGeom>
+        </p:spPr>
+      </p:pic>
       <p:sp>
         <p:nvSpPr>
           <p:cNvPr id="6" name="Rectangle 5"/>
@@ -7666,14 +7342,14 @@
         </p:nvSpPr>
         <p:spPr>
           <a:xfrm>
-            <a:off x="731520" y="1444752"/>
+            <a:off x="731520" y="1353312"/>
             <a:ext cx="10728655" cy="27432"/>
           </a:xfrm>
           <a:prstGeom prst="rect">
             <a:avLst/>
           </a:prstGeom>
           <a:solidFill>
-            <a:srgbClr val="A3000C"/>
+            <a:srgbClr val="E60012"/>
           </a:solidFill>
           <a:ln>
             <a:noFill/>
@@ -7709,7 +7385,7 @@
         </p:nvSpPr>
         <p:spPr>
           <a:xfrm>
-            <a:off x="685800" y="1554480"/>
+            <a:off x="685800" y="1481328"/>
             <a:ext cx="10789920" cy="457200"/>
           </a:xfrm>
           <a:prstGeom prst="rect">
@@ -7724,9 +7400,9 @@
           <a:lstStyle/>
           <a:p>
             <a:pPr>
-              <a:defRPr sz="1200">
-                <a:solidFill>
-                  <a:srgbClr val="AAAAB4"/>
+              <a:defRPr sz="1150">
+                <a:solidFill>
+                  <a:srgbClr val="F6F4EF"/>
                 </a:solidFill>
                 <a:latin typeface="Arial"/>
               </a:defRPr>
@@ -7745,18 +7421,18 @@
         </p:nvSpPr>
         <p:spPr>
           <a:xfrm>
-            <a:off x="731520" y="2148840"/>
-            <a:ext cx="5242255" cy="1234440"/>
+            <a:off x="731520" y="2057400"/>
+            <a:ext cx="5242255" cy="1261872"/>
           </a:xfrm>
           <a:prstGeom prst="rect">
             <a:avLst/>
           </a:prstGeom>
           <a:solidFill>
-            <a:srgbClr val="1A1A20"/>
+            <a:srgbClr val="0F0F14"/>
           </a:solidFill>
-          <a:ln w="12700">
+          <a:ln w="19050">
             <a:solidFill>
-              <a:srgbClr val="3C3C46"/>
+              <a:srgbClr val="E60012"/>
             </a:solidFill>
           </a:ln>
         </p:spPr>
@@ -7779,20 +7455,20 @@
           <a:lstStyle/>
           <a:p>
             <a:pPr algn="ctr">
-              <a:defRPr sz="1200" b="1">
-                <a:solidFill>
-                  <a:srgbClr val="E60012"/>
+              <a:defRPr sz="1150" b="1">
+                <a:solidFill>
+                  <a:srgbClr val="F1E05A"/>
                 </a:solidFill>
                 <a:latin typeface="Arial Black"/>
               </a:defRPr>
             </a:pPr>
             <a:r>
-              <a:t>01. EKSPANSI LAYANAN DIGITAL</a:t>
-            </a:r>
-          </a:p>
-          <a:p>
-            <a:pPr>
-              <a:defRPr sz="1000">
+              <a:t>★ 01. EKSPANSI LAYANAN DIGITAL</a:t>
+            </a:r>
+          </a:p>
+          <a:p>
+            <a:pPr>
+              <a:defRPr sz="950">
                 <a:solidFill>
                   <a:srgbClr val="F6F4EF"/>
                 </a:solidFill>
@@ -7813,18 +7489,18 @@
         </p:nvSpPr>
         <p:spPr>
           <a:xfrm>
-            <a:off x="6217920" y="2148840"/>
-            <a:ext cx="5242255" cy="1234440"/>
+            <a:off x="6217920" y="2057400"/>
+            <a:ext cx="5242255" cy="1261872"/>
           </a:xfrm>
           <a:prstGeom prst="rect">
             <a:avLst/>
           </a:prstGeom>
           <a:solidFill>
-            <a:srgbClr val="1A1A20"/>
+            <a:srgbClr val="0F0F14"/>
           </a:solidFill>
-          <a:ln w="12700">
+          <a:ln w="19050">
             <a:solidFill>
-              <a:srgbClr val="3C3C46"/>
+              <a:srgbClr val="E60012"/>
             </a:solidFill>
           </a:ln>
         </p:spPr>
@@ -7847,20 +7523,20 @@
           <a:lstStyle/>
           <a:p>
             <a:pPr algn="ctr">
-              <a:defRPr sz="1200" b="1">
-                <a:solidFill>
-                  <a:srgbClr val="E60012"/>
+              <a:defRPr sz="1150" b="1">
+                <a:solidFill>
+                  <a:srgbClr val="F1E05A"/>
                 </a:solidFill>
                 <a:latin typeface="Arial Black"/>
               </a:defRPr>
             </a:pPr>
             <a:r>
-              <a:t>02. PENINGKATAN MUTU LAYANAN</a:t>
-            </a:r>
-          </a:p>
-          <a:p>
-            <a:pPr>
-              <a:defRPr sz="1000">
+              <a:t>★ 02. PENINGKATAN MUTU LAYANAN</a:t>
+            </a:r>
+          </a:p>
+          <a:p>
+            <a:pPr>
+              <a:defRPr sz="950">
                 <a:solidFill>
                   <a:srgbClr val="F6F4EF"/>
                 </a:solidFill>
@@ -7881,18 +7557,18 @@
         </p:nvSpPr>
         <p:spPr>
           <a:xfrm>
-            <a:off x="731520" y="3502152"/>
-            <a:ext cx="5242255" cy="1234440"/>
+            <a:off x="731520" y="3447288"/>
+            <a:ext cx="5242255" cy="1261872"/>
           </a:xfrm>
           <a:prstGeom prst="rect">
             <a:avLst/>
           </a:prstGeom>
           <a:solidFill>
-            <a:srgbClr val="1A1A20"/>
+            <a:srgbClr val="0F0F14"/>
           </a:solidFill>
-          <a:ln w="12700">
+          <a:ln w="19050">
             <a:solidFill>
-              <a:srgbClr val="3C3C46"/>
+              <a:srgbClr val="E60012"/>
             </a:solidFill>
           </a:ln>
         </p:spPr>
@@ -7915,20 +7591,20 @@
           <a:lstStyle/>
           <a:p>
             <a:pPr algn="ctr">
-              <a:defRPr sz="1200" b="1">
-                <a:solidFill>
-                  <a:srgbClr val="E60012"/>
+              <a:defRPr sz="1150" b="1">
+                <a:solidFill>
+                  <a:srgbClr val="F1E05A"/>
                 </a:solidFill>
                 <a:latin typeface="Arial Black"/>
               </a:defRPr>
             </a:pPr>
             <a:r>
-              <a:t>03. OTOMASI BOT (@Sanzstrnokosmumerbot)</a:t>
-            </a:r>
-          </a:p>
-          <a:p>
-            <a:pPr>
-              <a:defRPr sz="1000">
+              <a:t>★ 03. OTOMASI BOT (@Sanzstrnokosmumerbot)</a:t>
+            </a:r>
+          </a:p>
+          <a:p>
+            <a:pPr>
+              <a:defRPr sz="950">
                 <a:solidFill>
                   <a:srgbClr val="F6F4EF"/>
                 </a:solidFill>
@@ -7949,18 +7625,18 @@
         </p:nvSpPr>
         <p:spPr>
           <a:xfrm>
-            <a:off x="6217920" y="3502152"/>
-            <a:ext cx="5242255" cy="1234440"/>
+            <a:off x="6217920" y="3447288"/>
+            <a:ext cx="5242255" cy="1261872"/>
           </a:xfrm>
           <a:prstGeom prst="rect">
             <a:avLst/>
           </a:prstGeom>
           <a:solidFill>
-            <a:srgbClr val="1A1A20"/>
+            <a:srgbClr val="0F0F14"/>
           </a:solidFill>
-          <a:ln w="12700">
+          <a:ln w="19050">
             <a:solidFill>
-              <a:srgbClr val="3C3C46"/>
+              <a:srgbClr val="E60012"/>
             </a:solidFill>
           </a:ln>
         </p:spPr>
@@ -7983,20 +7659,20 @@
           <a:lstStyle/>
           <a:p>
             <a:pPr algn="ctr">
-              <a:defRPr sz="1200" b="1">
-                <a:solidFill>
-                  <a:srgbClr val="E60012"/>
+              <a:defRPr sz="1150" b="1">
+                <a:solidFill>
+                  <a:srgbClr val="F1E05A"/>
                 </a:solidFill>
                 <a:latin typeface="Arial Black"/>
               </a:defRPr>
             </a:pPr>
             <a:r>
-              <a:t>04. SISTEM PENCATATAN &amp; PEMBUKUAN</a:t>
-            </a:r>
-          </a:p>
-          <a:p>
-            <a:pPr>
-              <a:defRPr sz="1000">
+              <a:t>★ 04. SISTEM PENCATATAN &amp; PEMBUKUAN</a:t>
+            </a:r>
+          </a:p>
+          <a:p>
+            <a:pPr>
+              <a:defRPr sz="950">
                 <a:solidFill>
                   <a:srgbClr val="F6F4EF"/>
                 </a:solidFill>
@@ -8017,18 +7693,18 @@
         </p:nvSpPr>
         <p:spPr>
           <a:xfrm>
-            <a:off x="731520" y="4855464"/>
-            <a:ext cx="5242255" cy="1234440"/>
+            <a:off x="731520" y="4837176"/>
+            <a:ext cx="5242255" cy="1261872"/>
           </a:xfrm>
           <a:prstGeom prst="rect">
             <a:avLst/>
           </a:prstGeom>
           <a:solidFill>
-            <a:srgbClr val="1A1A20"/>
+            <a:srgbClr val="0F0F14"/>
           </a:solidFill>
-          <a:ln w="12700">
+          <a:ln w="19050">
             <a:solidFill>
-              <a:srgbClr val="3C3C46"/>
+              <a:srgbClr val="E60012"/>
             </a:solidFill>
           </a:ln>
         </p:spPr>
@@ -8051,20 +7727,20 @@
           <a:lstStyle/>
           <a:p>
             <a:pPr algn="ctr">
-              <a:defRPr sz="1200" b="1">
-                <a:solidFill>
-                  <a:srgbClr val="E60012"/>
+              <a:defRPr sz="1150" b="1">
+                <a:solidFill>
+                  <a:srgbClr val="F1E05A"/>
                 </a:solidFill>
                 <a:latin typeface="Arial Black"/>
               </a:defRPr>
             </a:pPr>
             <a:r>
-              <a:t>05. KEAMANAN &amp; KEANDALAN SISTEM</a:t>
-            </a:r>
-          </a:p>
-          <a:p>
-            <a:pPr>
-              <a:defRPr sz="1000">
+              <a:t>★ 05. KEAMANAN &amp; KEANDALAN SISTEM</a:t>
+            </a:r>
+          </a:p>
+          <a:p>
+            <a:pPr>
+              <a:defRPr sz="950">
                 <a:solidFill>
                   <a:srgbClr val="F6F4EF"/>
                 </a:solidFill>
@@ -8085,18 +7761,18 @@
         </p:nvSpPr>
         <p:spPr>
           <a:xfrm>
-            <a:off x="6217920" y="4855464"/>
-            <a:ext cx="5242255" cy="1234440"/>
+            <a:off x="6217920" y="4837176"/>
+            <a:ext cx="5242255" cy="1261872"/>
           </a:xfrm>
           <a:prstGeom prst="rect">
             <a:avLst/>
           </a:prstGeom>
           <a:solidFill>
-            <a:srgbClr val="1A1A20"/>
+            <a:srgbClr val="0F0F14"/>
           </a:solidFill>
-          <a:ln w="12700">
+          <a:ln w="19050">
             <a:solidFill>
-              <a:srgbClr val="3C3C46"/>
+              <a:srgbClr val="E60012"/>
             </a:solidFill>
           </a:ln>
         </p:spPr>
@@ -8119,20 +7795,20 @@
           <a:lstStyle/>
           <a:p>
             <a:pPr algn="ctr">
-              <a:defRPr sz="1200" b="1">
-                <a:solidFill>
-                  <a:srgbClr val="E60012"/>
+              <a:defRPr sz="1150" b="1">
+                <a:solidFill>
+                  <a:srgbClr val="F1E05A"/>
                 </a:solidFill>
                 <a:latin typeface="Arial Black"/>
               </a:defRPr>
             </a:pPr>
             <a:r>
-              <a:t>06. EKOSISTEM BERKELANJUTAN</a:t>
-            </a:r>
-          </a:p>
-          <a:p>
-            <a:pPr>
-              <a:defRPr sz="1000">
+              <a:t>★ 06. EKOSISTEM BERKELANJUTAN</a:t>
+            </a:r>
+          </a:p>
+          <a:p>
+            <a:pPr>
+              <a:defRPr sz="950">
                 <a:solidFill>
                   <a:srgbClr val="F6F4EF"/>
                 </a:solidFill>
@@ -8170,7 +7846,7 @@
             <a:pPr>
               <a:defRPr sz="1000">
                 <a:solidFill>
-                  <a:srgbClr val="AAAAB4"/>
+                  <a:srgbClr val="AFAFBE"/>
                 </a:solidFill>
                 <a:latin typeface="Arial"/>
               </a:defRPr>
@@ -8199,12 +7875,20 @@
         <p:nvPr/>
       </p:nvGrpSpPr>
       <p:grpSpPr/>
-      <p:sp>
-        <p:nvSpPr>
-          <p:cNvPr id="2" name="Rectangle 1"/>
-          <p:cNvSpPr/>
+      <p:pic>
+        <p:nvPicPr>
+          <p:cNvPr id="2" name="Picture 1" descr="bg_slide5.jpg"/>
+          <p:cNvPicPr>
+            <a:picLocks noChangeAspect="1"/>
+          </p:cNvPicPr>
           <p:nvPr/>
-        </p:nvSpPr>
+        </p:nvPicPr>
+        <p:blipFill>
+          <a:blip r:embed="rId2"/>
+          <a:stretch>
+            <a:fillRect/>
+          </a:stretch>
+        </p:blipFill>
         <p:spPr>
           <a:xfrm>
             <a:off x="0" y="0"/>
@@ -8213,35 +7897,8 @@
           <a:prstGeom prst="rect">
             <a:avLst/>
           </a:prstGeom>
-          <a:solidFill>
-            <a:srgbClr val="0E0E11"/>
-          </a:solidFill>
-          <a:ln>
-            <a:noFill/>
-          </a:ln>
-        </p:spPr>
-        <p:style>
-          <a:lnRef idx="1">
-            <a:schemeClr val="accent1"/>
-          </a:lnRef>
-          <a:fillRef idx="3">
-            <a:schemeClr val="accent1"/>
-          </a:fillRef>
-          <a:effectRef idx="2">
-            <a:schemeClr val="accent1"/>
-          </a:effectRef>
-          <a:fontRef idx="minor">
-            <a:schemeClr val="lt1"/>
-          </a:fontRef>
-        </p:style>
-        <p:txBody>
-          <a:bodyPr rtlCol="0" anchor="ctr"/>
-          <a:lstStyle/>
-          <a:p>
-            <a:pPr algn="ctr"/>
-          </a:p>
-        </p:txBody>
-      </p:sp>
+        </p:spPr>
+      </p:pic>
       <p:sp>
         <p:nvSpPr>
           <p:cNvPr id="3" name="Rectangle 2"/>
@@ -8293,8 +7950,8 @@
         </p:nvSpPr>
         <p:spPr>
           <a:xfrm>
-            <a:off x="731520" y="365760"/>
-            <a:ext cx="2560320" cy="347472"/>
+            <a:off x="731520" y="320040"/>
+            <a:ext cx="2926080" cy="329184"/>
           </a:xfrm>
           <a:prstGeom prst="rect">
             <a:avLst/>
@@ -8321,7 +7978,7 @@
           </a:fontRef>
         </p:style>
         <p:txBody>
-          <a:bodyPr rtlCol="0" anchor="ctr" wrap="square" tIns="36576"/>
+          <a:bodyPr rtlCol="0" anchor="ctr" wrap="square" lIns="109728" tIns="36576"/>
           <a:lstStyle/>
           <a:p>
             <a:pPr algn="ctr">
@@ -8338,42 +7995,30 @@
           </a:p>
         </p:txBody>
       </p:sp>
-      <p:sp>
-        <p:nvSpPr>
-          <p:cNvPr id="5" name="TextBox 4"/>
-          <p:cNvSpPr txBox="1"/>
+      <p:pic>
+        <p:nvPicPr>
+          <p:cNvPr id="5" name="Picture 4" descr="title_8.png"/>
+          <p:cNvPicPr>
+            <a:picLocks noChangeAspect="1"/>
+          </p:cNvPicPr>
           <p:nvPr/>
-        </p:nvSpPr>
-        <p:spPr>
-          <a:xfrm>
-            <a:off x="685800" y="777240"/>
-            <a:ext cx="10789920" cy="640080"/>
-          </a:xfrm>
-          <a:prstGeom prst="rect">
-            <a:avLst/>
-          </a:prstGeom>
-          <a:noFill/>
-        </p:spPr>
-        <p:txBody>
-          <a:bodyPr wrap="square">
-            <a:spAutoFit/>
-          </a:bodyPr>
-          <a:lstStyle/>
-          <a:p>
-            <a:pPr>
-              <a:defRPr sz="2400" b="1">
-                <a:solidFill>
-                  <a:srgbClr val="F6F4EF"/>
-                </a:solidFill>
-                <a:latin typeface="Arial Black"/>
-              </a:defRPr>
-            </a:pPr>
-            <a:r>
-              <a:t>KESIMPULAN BISNIS</a:t>
-            </a:r>
-          </a:p>
-        </p:txBody>
-      </p:sp>
+        </p:nvPicPr>
+        <p:blipFill>
+          <a:blip r:embed="rId3"/>
+          <a:stretch>
+            <a:fillRect/>
+          </a:stretch>
+        </p:blipFill>
+        <p:spPr>
+          <a:xfrm>
+            <a:off x="713232" y="694944"/>
+            <a:ext cx="6858323" cy="566928"/>
+          </a:xfrm>
+          <a:prstGeom prst="rect">
+            <a:avLst/>
+          </a:prstGeom>
+        </p:spPr>
+      </p:pic>
       <p:sp>
         <p:nvSpPr>
           <p:cNvPr id="6" name="Rectangle 5"/>
@@ -8382,14 +8027,14 @@
         </p:nvSpPr>
         <p:spPr>
           <a:xfrm>
-            <a:off x="731520" y="1444752"/>
+            <a:off x="731520" y="1353312"/>
             <a:ext cx="10728655" cy="27432"/>
           </a:xfrm>
           <a:prstGeom prst="rect">
             <a:avLst/>
           </a:prstGeom>
           <a:solidFill>
-            <a:srgbClr val="A3000C"/>
+            <a:srgbClr val="E60012"/>
           </a:solidFill>
           <a:ln>
             <a:noFill/>
@@ -8425,14 +8070,14 @@
         </p:nvSpPr>
         <p:spPr>
           <a:xfrm>
-            <a:off x="731520" y="1691640"/>
-            <a:ext cx="10728655" cy="2377440"/>
+            <a:off x="731520" y="1600200"/>
+            <a:ext cx="10728655" cy="2423160"/>
           </a:xfrm>
           <a:prstGeom prst="rect">
             <a:avLst/>
           </a:prstGeom>
           <a:solidFill>
-            <a:srgbClr val="1A1A20"/>
+            <a:srgbClr val="0F0F14"/>
           </a:solidFill>
           <a:ln w="25400">
             <a:solidFill>
@@ -8455,11 +8100,11 @@
           </a:fontRef>
         </p:style>
         <p:txBody>
-          <a:bodyPr rtlCol="0" anchor="ctr" wrap="square" lIns="365760" rIns="365760" tIns="274320"/>
+          <a:bodyPr rtlCol="0" anchor="ctr" wrap="square" lIns="320040" rIns="320040" tIns="228600"/>
           <a:lstStyle/>
           <a:p>
             <a:pPr algn="ctr">
-              <a:defRPr sz="1200">
+              <a:defRPr sz="1200" b="1">
                 <a:solidFill>
                   <a:srgbClr val="F1E05A"/>
                 </a:solidFill>
@@ -8467,7 +8112,7 @@
               </a:defRPr>
             </a:pPr>
             <a:r>
-              <a:t>KESIMPULAN EKSEKUTIF</a:t>
+              <a:t>★ KESIMPULAN EKSEKUTIF</a:t>
             </a:r>
           </a:p>
           <a:p>
@@ -8475,7 +8120,7 @@
               <a:spcBef>
                 <a:spcPts val="800"/>
               </a:spcBef>
-              <a:defRPr sz="1350">
+              <a:defRPr sz="1300">
                 <a:solidFill>
                   <a:srgbClr val="F6F4EF"/>
                 </a:solidFill>
@@ -8512,8 +8157,8 @@
         </p:nvSpPr>
         <p:spPr>
           <a:xfrm>
-            <a:off x="731520" y="4297680"/>
-            <a:ext cx="4114800" cy="1920240"/>
+            <a:off x="731520" y="4251960"/>
+            <a:ext cx="4114800" cy="1965960"/>
           </a:xfrm>
           <a:prstGeom prst="rect">
             <a:avLst/>
@@ -8540,7 +8185,7 @@
           </a:fontRef>
         </p:style>
         <p:txBody>
-          <a:bodyPr rtlCol="0" anchor="ctr" wrap="square" lIns="274320" tIns="411480"/>
+          <a:bodyPr rtlCol="0" anchor="ctr" wrap="square" lIns="274320" tIns="320040"/>
           <a:lstStyle/>
           <a:p>
             <a:pPr algn="ctr">
@@ -8571,6 +8216,22 @@
               <a:t>Presentasi Portofolio Bisnis Selesai.</a:t>
             </a:r>
           </a:p>
+          <a:p>
+            <a:pPr>
+              <a:spcBef>
+                <a:spcPts val="400"/>
+              </a:spcBef>
+              <a:defRPr sz="1100" b="1">
+                <a:solidFill>
+                  <a:srgbClr val="F1E05A"/>
+                </a:solidFill>
+                <a:latin typeface="Arial Black"/>
+              </a:defRPr>
+            </a:pPr>
+            <a:r>
+              <a:t>Solusi Digital Cepat, Transparan, &amp; Andal.</a:t>
+            </a:r>
+          </a:p>
         </p:txBody>
       </p:sp>
       <p:sp>
@@ -8581,18 +8242,18 @@
         </p:nvSpPr>
         <p:spPr>
           <a:xfrm>
-            <a:off x="5029200" y="4297680"/>
-            <a:ext cx="6430975" cy="1920240"/>
+            <a:off x="5029200" y="4251960"/>
+            <a:ext cx="6430975" cy="1965960"/>
           </a:xfrm>
           <a:prstGeom prst="rect">
             <a:avLst/>
           </a:prstGeom>
           <a:solidFill>
-            <a:srgbClr val="1A1A20"/>
+            <a:srgbClr val="0F0F14"/>
           </a:solidFill>
           <a:ln w="12700">
             <a:solidFill>
-              <a:srgbClr val="3C3C46"/>
+              <a:srgbClr val="3C3C48"/>
             </a:solidFill>
           </a:ln>
         </p:spPr>
@@ -8611,7 +8272,7 @@
           </a:fontRef>
         </p:style>
         <p:txBody>
-          <a:bodyPr rtlCol="0" anchor="ctr" wrap="square" lIns="274320" tIns="182880"/>
+          <a:bodyPr rtlCol="0" anchor="ctr" wrap="square" lIns="274320" tIns="164592"/>
           <a:lstStyle/>
           <a:p>
             <a:pPr algn="ctr">
@@ -8733,7 +8394,7 @@
             <a:pPr>
               <a:defRPr sz="1000">
                 <a:solidFill>
-                  <a:srgbClr val="AAAAB4"/>
+                  <a:srgbClr val="AFAFBE"/>
                 </a:solidFill>
                 <a:latin typeface="Arial"/>
               </a:defRPr>

</xml_diff>